<commit_message>
docs(idts-100): finalize mentor-ready SAP490 pack
</commit_message>
<xml_diff>
--- a/docs/diagrams/rendered/SU26SAP01_GSU26SAP01_Diagram_Pack_v1_0_20260711.pptx
+++ b/docs/diagrams/rendered/SU26SAP01_GSU26SAP01_Diagram_Pack_v1_0_20260711.pptx
@@ -6,51 +6,51 @@
   </p:sldMasterIdLst>
   <p:sldIdLst>
     <p:sldId id="256" r:id="rId7"/>
-    <p:sldId id="257" r:id="rId8"/>
-    <p:sldId id="258" r:id="rId9"/>
-    <p:sldId id="259" r:id="rId10"/>
-    <p:sldId id="260" r:id="rId11"/>
-    <p:sldId id="261" r:id="rId12"/>
-    <p:sldId id="262" r:id="rId13"/>
-    <p:sldId id="263" r:id="rId14"/>
-    <p:sldId id="264" r:id="rId15"/>
-    <p:sldId id="265" r:id="rId16"/>
-    <p:sldId id="266" r:id="rId17"/>
-    <p:sldId id="267" r:id="rId18"/>
-    <p:sldId id="268" r:id="rId19"/>
-    <p:sldId id="269" r:id="rId20"/>
-    <p:sldId id="270" r:id="rId21"/>
-    <p:sldId id="271" r:id="rId22"/>
-    <p:sldId id="272" r:id="rId23"/>
-    <p:sldId id="273" r:id="rId24"/>
-    <p:sldId id="274" r:id="rId25"/>
-    <p:sldId id="275" r:id="rId26"/>
-    <p:sldId id="276" r:id="rId27"/>
-    <p:sldId id="277" r:id="rId28"/>
-    <p:sldId id="278" r:id="rId29"/>
-    <p:sldId id="279" r:id="rId30"/>
-    <p:sldId id="280" r:id="rId31"/>
-    <p:sldId id="281" r:id="rId32"/>
-    <p:sldId id="282" r:id="rId33"/>
-    <p:sldId id="283" r:id="rId34"/>
-    <p:sldId id="284" r:id="rId35"/>
-    <p:sldId id="285" r:id="rId36"/>
-    <p:sldId id="286" r:id="rId37"/>
-    <p:sldId id="287" r:id="rId38"/>
-    <p:sldId id="288" r:id="rId39"/>
-    <p:sldId id="289" r:id="rId40"/>
-    <p:sldId id="290" r:id="rId41"/>
-    <p:sldId id="291" r:id="rId42"/>
-    <p:sldId id="292" r:id="rId43"/>
-    <p:sldId id="293" r:id="rId44"/>
-    <p:sldId id="294" r:id="rId45"/>
-    <p:sldId id="295" r:id="rId46"/>
-    <p:sldId id="296" r:id="rId47"/>
-    <p:sldId id="297" r:id="rId48"/>
-    <p:sldId id="298" r:id="rId49"/>
-    <p:sldId id="299" r:id="rId50"/>
-    <p:sldId id="300" r:id="rId51"/>
-    <p:sldId id="301" r:id="rId52"/>
+    <p:sldId id="257" r:id="rId9"/>
+    <p:sldId id="258" r:id="rId10"/>
+    <p:sldId id="259" r:id="rId11"/>
+    <p:sldId id="260" r:id="rId12"/>
+    <p:sldId id="261" r:id="rId13"/>
+    <p:sldId id="262" r:id="rId14"/>
+    <p:sldId id="263" r:id="rId15"/>
+    <p:sldId id="264" r:id="rId16"/>
+    <p:sldId id="265" r:id="rId17"/>
+    <p:sldId id="266" r:id="rId18"/>
+    <p:sldId id="267" r:id="rId19"/>
+    <p:sldId id="268" r:id="rId20"/>
+    <p:sldId id="269" r:id="rId21"/>
+    <p:sldId id="270" r:id="rId22"/>
+    <p:sldId id="271" r:id="rId23"/>
+    <p:sldId id="272" r:id="rId24"/>
+    <p:sldId id="273" r:id="rId25"/>
+    <p:sldId id="274" r:id="rId26"/>
+    <p:sldId id="275" r:id="rId27"/>
+    <p:sldId id="276" r:id="rId28"/>
+    <p:sldId id="277" r:id="rId29"/>
+    <p:sldId id="278" r:id="rId30"/>
+    <p:sldId id="279" r:id="rId31"/>
+    <p:sldId id="280" r:id="rId32"/>
+    <p:sldId id="281" r:id="rId33"/>
+    <p:sldId id="282" r:id="rId34"/>
+    <p:sldId id="283" r:id="rId35"/>
+    <p:sldId id="284" r:id="rId36"/>
+    <p:sldId id="285" r:id="rId37"/>
+    <p:sldId id="286" r:id="rId38"/>
+    <p:sldId id="287" r:id="rId39"/>
+    <p:sldId id="288" r:id="rId40"/>
+    <p:sldId id="289" r:id="rId41"/>
+    <p:sldId id="290" r:id="rId42"/>
+    <p:sldId id="291" r:id="rId43"/>
+    <p:sldId id="292" r:id="rId44"/>
+    <p:sldId id="293" r:id="rId45"/>
+    <p:sldId id="294" r:id="rId46"/>
+    <p:sldId id="295" r:id="rId47"/>
+    <p:sldId id="296" r:id="rId48"/>
+    <p:sldId id="297" r:id="rId49"/>
+    <p:sldId id="298" r:id="rId50"/>
+    <p:sldId id="299" r:id="rId51"/>
+    <p:sldId id="300" r:id="rId52"/>
+    <p:sldId id="301" r:id="rId53"/>
   </p:sldIdLst>
   <p:sldSz cx="12191695" cy="6858000" type="screen4x3"/>
   <p:notesSz cx="6858000" cy="9144000"/>
@@ -150,6 +150,3576 @@
     </a:lvl9pPr>
   </p:defaultTextStyle>
 </p:presentation>
+</file>
+
+<file path=ppt/notesMasters/notesMaster1.xml><?xml version="1.0" encoding="utf-8"?>
+<p:notesMaster xmlns:a="http://schemas.openxmlformats.org/drawingml/2006/main" xmlns:p="http://schemas.openxmlformats.org/presentationml/2006/main" xmlns:r="http://schemas.openxmlformats.org/officeDocument/2006/relationships">
+  <p:cSld>
+    <p:bg>
+      <p:bgRef idx="1001">
+        <a:schemeClr val="bg1"/>
+      </p:bgRef>
+    </p:bg>
+    <p:spTree>
+      <p:nvGrpSpPr>
+        <p:cNvPr id="1" name=""/>
+        <p:cNvGrpSpPr/>
+        <p:nvPr/>
+      </p:nvGrpSpPr>
+      <p:grpSpPr>
+        <a:xfrm>
+          <a:off x="0" y="0"/>
+          <a:ext cx="0" cy="0"/>
+          <a:chOff x="0" y="0"/>
+          <a:chExt cx="0" cy="0"/>
+        </a:xfrm>
+      </p:grpSpPr>
+      <p:sp>
+        <p:nvSpPr>
+          <p:cNvPr id="2" name="Header Placeholder 1"/>
+          <p:cNvSpPr>
+            <a:spLocks noGrp="1"/>
+          </p:cNvSpPr>
+          <p:nvPr>
+            <p:ph type="hdr" sz="quarter"/>
+          </p:nvPr>
+        </p:nvSpPr>
+        <p:spPr>
+          <a:xfrm>
+            <a:off x="0" y="0"/>
+            <a:ext cx="2971800" cy="457200"/>
+          </a:xfrm>
+          <a:prstGeom prst="rect">
+            <a:avLst/>
+          </a:prstGeom>
+        </p:spPr>
+        <p:txBody>
+          <a:bodyPr vert="horz" lIns="91440" tIns="45720" rIns="91440" bIns="45720" rtlCol="0"/>
+          <a:lstStyle>
+            <a:lvl1pPr algn="l">
+              <a:defRPr sz="1200"/>
+            </a:lvl1pPr>
+          </a:lstStyle>
+          <a:p>
+            <a:endParaRPr lang="en-US"/>
+          </a:p>
+        </p:txBody>
+      </p:sp>
+      <p:sp>
+        <p:nvSpPr>
+          <p:cNvPr id="3" name="Date Placeholder 2"/>
+          <p:cNvSpPr>
+            <a:spLocks noGrp="1"/>
+          </p:cNvSpPr>
+          <p:nvPr>
+            <p:ph type="dt" idx="1"/>
+          </p:nvPr>
+        </p:nvSpPr>
+        <p:spPr>
+          <a:xfrm>
+            <a:off x="3884613" y="0"/>
+            <a:ext cx="2971800" cy="457200"/>
+          </a:xfrm>
+          <a:prstGeom prst="rect">
+            <a:avLst/>
+          </a:prstGeom>
+        </p:spPr>
+        <p:txBody>
+          <a:bodyPr vert="horz" lIns="91440" tIns="45720" rIns="91440" bIns="45720" rtlCol="0"/>
+          <a:lstStyle>
+            <a:lvl1pPr algn="r">
+              <a:defRPr sz="1200"/>
+            </a:lvl1pPr>
+          </a:lstStyle>
+          <a:p>
+            <a:fld id="{0F89C1C7-3DCD-1040-A9CF-14679D8B5DDD}" type="datetimeFigureOut">
+              <a:rPr lang="en-US" smtClean="0"/>
+              <a:t>10/17/16</a:t>
+            </a:fld>
+            <a:endParaRPr lang="en-US"/>
+          </a:p>
+        </p:txBody>
+      </p:sp>
+      <p:sp>
+        <p:nvSpPr>
+          <p:cNvPr id="4" name="Slide Image Placeholder 3"/>
+          <p:cNvSpPr>
+            <a:spLocks noGrp="1" noRot="1" noChangeAspect="1"/>
+          </p:cNvSpPr>
+          <p:nvPr>
+            <p:ph type="sldImg" idx="2"/>
+          </p:nvPr>
+        </p:nvSpPr>
+        <p:spPr>
+          <a:xfrm>
+            <a:off x="1143000" y="685800"/>
+            <a:ext cx="4572000" cy="3429000"/>
+          </a:xfrm>
+          <a:prstGeom prst="rect">
+            <a:avLst/>
+          </a:prstGeom>
+          <a:noFill/>
+          <a:ln w="12700">
+            <a:solidFill>
+              <a:prstClr val="black"/>
+            </a:solidFill>
+          </a:ln>
+        </p:spPr>
+        <p:txBody>
+          <a:bodyPr vert="horz" lIns="91440" tIns="45720" rIns="91440" bIns="45720" rtlCol="0" anchor="ctr"/>
+          <a:lstStyle/>
+          <a:p>
+            <a:endParaRPr lang="en-US"/>
+          </a:p>
+        </p:txBody>
+      </p:sp>
+      <p:sp>
+        <p:nvSpPr>
+          <p:cNvPr id="5" name="Notes Placeholder 4"/>
+          <p:cNvSpPr>
+            <a:spLocks noGrp="1"/>
+          </p:cNvSpPr>
+          <p:nvPr>
+            <p:ph type="body" sz="quarter" idx="3"/>
+          </p:nvPr>
+        </p:nvSpPr>
+        <p:spPr>
+          <a:xfrm>
+            <a:off x="685800" y="4343400"/>
+            <a:ext cx="5486400" cy="4114800"/>
+          </a:xfrm>
+          <a:prstGeom prst="rect">
+            <a:avLst/>
+          </a:prstGeom>
+        </p:spPr>
+        <p:txBody>
+          <a:bodyPr vert="horz" lIns="91440" tIns="45720" rIns="91440" bIns="45720" rtlCol="0"/>
+          <a:lstStyle/>
+          <a:p>
+            <a:pPr lvl="0"/>
+            <a:r>
+              <a:rPr lang="en-US" smtClean="0"/>
+              <a:t>Click to edit Master text styles</a:t>
+            </a:r>
+          </a:p>
+          <a:p>
+            <a:pPr lvl="1"/>
+            <a:r>
+              <a:rPr lang="en-US" smtClean="0"/>
+              <a:t>Second level</a:t>
+            </a:r>
+          </a:p>
+          <a:p>
+            <a:pPr lvl="2"/>
+            <a:r>
+              <a:rPr lang="en-US" smtClean="0"/>
+              <a:t>Third level</a:t>
+            </a:r>
+          </a:p>
+          <a:p>
+            <a:pPr lvl="3"/>
+            <a:r>
+              <a:rPr lang="en-US" smtClean="0"/>
+              <a:t>Fourth level</a:t>
+            </a:r>
+          </a:p>
+          <a:p>
+            <a:pPr lvl="4"/>
+            <a:r>
+              <a:rPr lang="en-US" smtClean="0"/>
+              <a:t>Fifth level</a:t>
+            </a:r>
+            <a:endParaRPr lang="en-US"/>
+          </a:p>
+        </p:txBody>
+      </p:sp>
+      <p:sp>
+        <p:nvSpPr>
+          <p:cNvPr id="6" name="Footer Placeholder 5"/>
+          <p:cNvSpPr>
+            <a:spLocks noGrp="1"/>
+          </p:cNvSpPr>
+          <p:nvPr>
+            <p:ph type="ftr" sz="quarter" idx="4"/>
+          </p:nvPr>
+        </p:nvSpPr>
+        <p:spPr>
+          <a:xfrm>
+            <a:off x="0" y="8685213"/>
+            <a:ext cx="2971800" cy="457200"/>
+          </a:xfrm>
+          <a:prstGeom prst="rect">
+            <a:avLst/>
+          </a:prstGeom>
+        </p:spPr>
+        <p:txBody>
+          <a:bodyPr vert="horz" lIns="91440" tIns="45720" rIns="91440" bIns="45720" rtlCol="0" anchor="b"/>
+          <a:lstStyle>
+            <a:lvl1pPr algn="l">
+              <a:defRPr sz="1200"/>
+            </a:lvl1pPr>
+          </a:lstStyle>
+          <a:p>
+            <a:endParaRPr lang="en-US"/>
+          </a:p>
+        </p:txBody>
+      </p:sp>
+      <p:sp>
+        <p:nvSpPr>
+          <p:cNvPr id="7" name="Slide Number Placeholder 6"/>
+          <p:cNvSpPr>
+            <a:spLocks noGrp="1"/>
+          </p:cNvSpPr>
+          <p:nvPr>
+            <p:ph type="sldNum" sz="quarter" idx="5"/>
+          </p:nvPr>
+        </p:nvSpPr>
+        <p:spPr>
+          <a:xfrm>
+            <a:off x="3884613" y="8685213"/>
+            <a:ext cx="2971800" cy="457200"/>
+          </a:xfrm>
+          <a:prstGeom prst="rect">
+            <a:avLst/>
+          </a:prstGeom>
+        </p:spPr>
+        <p:txBody>
+          <a:bodyPr vert="horz" lIns="91440" tIns="45720" rIns="91440" bIns="45720" rtlCol="0" anchor="b"/>
+          <a:lstStyle>
+            <a:lvl1pPr algn="r">
+              <a:defRPr sz="1200"/>
+            </a:lvl1pPr>
+          </a:lstStyle>
+          <a:p>
+            <a:fld id="{BB5E49A5-4136-284D-997B-48E1D791AD67}" type="slidenum">
+              <a:rPr lang="en-US" smtClean="0"/>
+              <a:t>‹#›</a:t>
+            </a:fld>
+            <a:endParaRPr lang="en-US"/>
+          </a:p>
+        </p:txBody>
+      </p:sp>
+    </p:spTree>
+    <p:extLst>
+      <p:ext uri="{BB962C8B-B14F-4D97-AF65-F5344CB8AC3E}">
+        <p14:creationId xmlns:p14="http://schemas.microsoft.com/office/powerpoint/2010/main" val="2623252185"/>
+      </p:ext>
+    </p:extLst>
+  </p:cSld>
+  <p:clrMap bg1="lt1" tx1="dk1" bg2="lt2" tx2="dk2" accent1="accent1" accent2="accent2" accent3="accent3" accent4="accent4" accent5="accent5" accent6="accent6" hlink="hlink" folHlink="folHlink"/>
+  <p:notesStyle>
+    <a:lvl1pPr marL="0" algn="l" defTabSz="457200" rtl="0" eaLnBrk="1" latinLnBrk="0" hangingPunct="1">
+      <a:defRPr sz="1200" kern="1200">
+        <a:solidFill>
+          <a:schemeClr val="tx1"/>
+        </a:solidFill>
+        <a:latin typeface="+mn-lt"/>
+        <a:ea typeface="+mn-ea"/>
+        <a:cs typeface="+mn-cs"/>
+      </a:defRPr>
+    </a:lvl1pPr>
+    <a:lvl2pPr marL="457200" algn="l" defTabSz="457200" rtl="0" eaLnBrk="1" latinLnBrk="0" hangingPunct="1">
+      <a:defRPr sz="1200" kern="1200">
+        <a:solidFill>
+          <a:schemeClr val="tx1"/>
+        </a:solidFill>
+        <a:latin typeface="+mn-lt"/>
+        <a:ea typeface="+mn-ea"/>
+        <a:cs typeface="+mn-cs"/>
+      </a:defRPr>
+    </a:lvl2pPr>
+    <a:lvl3pPr marL="914400" algn="l" defTabSz="457200" rtl="0" eaLnBrk="1" latinLnBrk="0" hangingPunct="1">
+      <a:defRPr sz="1200" kern="1200">
+        <a:solidFill>
+          <a:schemeClr val="tx1"/>
+        </a:solidFill>
+        <a:latin typeface="+mn-lt"/>
+        <a:ea typeface="+mn-ea"/>
+        <a:cs typeface="+mn-cs"/>
+      </a:defRPr>
+    </a:lvl3pPr>
+    <a:lvl4pPr marL="1371600" algn="l" defTabSz="457200" rtl="0" eaLnBrk="1" latinLnBrk="0" hangingPunct="1">
+      <a:defRPr sz="1200" kern="1200">
+        <a:solidFill>
+          <a:schemeClr val="tx1"/>
+        </a:solidFill>
+        <a:latin typeface="+mn-lt"/>
+        <a:ea typeface="+mn-ea"/>
+        <a:cs typeface="+mn-cs"/>
+      </a:defRPr>
+    </a:lvl4pPr>
+    <a:lvl5pPr marL="1828800" algn="l" defTabSz="457200" rtl="0" eaLnBrk="1" latinLnBrk="0" hangingPunct="1">
+      <a:defRPr sz="1200" kern="1200">
+        <a:solidFill>
+          <a:schemeClr val="tx1"/>
+        </a:solidFill>
+        <a:latin typeface="+mn-lt"/>
+        <a:ea typeface="+mn-ea"/>
+        <a:cs typeface="+mn-cs"/>
+      </a:defRPr>
+    </a:lvl5pPr>
+    <a:lvl6pPr marL="2286000" algn="l" defTabSz="457200" rtl="0" eaLnBrk="1" latinLnBrk="0" hangingPunct="1">
+      <a:defRPr sz="1200" kern="1200">
+        <a:solidFill>
+          <a:schemeClr val="tx1"/>
+        </a:solidFill>
+        <a:latin typeface="+mn-lt"/>
+        <a:ea typeface="+mn-ea"/>
+        <a:cs typeface="+mn-cs"/>
+      </a:defRPr>
+    </a:lvl6pPr>
+    <a:lvl7pPr marL="2743200" algn="l" defTabSz="457200" rtl="0" eaLnBrk="1" latinLnBrk="0" hangingPunct="1">
+      <a:defRPr sz="1200" kern="1200">
+        <a:solidFill>
+          <a:schemeClr val="tx1"/>
+        </a:solidFill>
+        <a:latin typeface="+mn-lt"/>
+        <a:ea typeface="+mn-ea"/>
+        <a:cs typeface="+mn-cs"/>
+      </a:defRPr>
+    </a:lvl7pPr>
+    <a:lvl8pPr marL="3200400" algn="l" defTabSz="457200" rtl="0" eaLnBrk="1" latinLnBrk="0" hangingPunct="1">
+      <a:defRPr sz="1200" kern="1200">
+        <a:solidFill>
+          <a:schemeClr val="tx1"/>
+        </a:solidFill>
+        <a:latin typeface="+mn-lt"/>
+        <a:ea typeface="+mn-ea"/>
+        <a:cs typeface="+mn-cs"/>
+      </a:defRPr>
+    </a:lvl8pPr>
+    <a:lvl9pPr marL="3657600" algn="l" defTabSz="457200" rtl="0" eaLnBrk="1" latinLnBrk="0" hangingPunct="1">
+      <a:defRPr sz="1200" kern="1200">
+        <a:solidFill>
+          <a:schemeClr val="tx1"/>
+        </a:solidFill>
+        <a:latin typeface="+mn-lt"/>
+        <a:ea typeface="+mn-ea"/>
+        <a:cs typeface="+mn-cs"/>
+      </a:defRPr>
+    </a:lvl9pPr>
+  </p:notesStyle>
+</p:notesMaster>
+</file>
+
+<file path=ppt/notesSlides/notesSlide1.xml><?xml version="1.0" encoding="utf-8"?>
+<p:notes xmlns:a="http://schemas.openxmlformats.org/drawingml/2006/main" xmlns:p="http://schemas.openxmlformats.org/presentationml/2006/main" xmlns:r="http://schemas.openxmlformats.org/officeDocument/2006/relationships">
+  <p:cSld>
+    <p:spTree>
+      <p:nvGrpSpPr>
+        <p:cNvPr id="1" name=""/>
+        <p:cNvGrpSpPr/>
+        <p:nvPr/>
+      </p:nvGrpSpPr>
+      <p:grpSpPr>
+        <a:xfrm>
+          <a:off x="0" y="0"/>
+          <a:ext cx="0" cy="0"/>
+          <a:chOff x="0" y="0"/>
+          <a:chExt cx="0" cy="0"/>
+        </a:xfrm>
+      </p:grpSpPr>
+      <p:sp>
+        <p:nvSpPr>
+          <p:cNvPr id="2" name="Slide Image Placeholder 1"/>
+          <p:cNvSpPr>
+            <a:spLocks noGrp="1"/>
+          </p:cNvSpPr>
+          <p:nvPr>
+            <p:ph type="sldImg" idx="2"/>
+          </p:nvPr>
+        </p:nvSpPr>
+        <p:spPr/>
+      </p:sp>
+      <p:sp>
+        <p:nvSpPr>
+          <p:cNvPr id="3" name="Notes Placeholder 2"/>
+          <p:cNvSpPr>
+            <a:spLocks noGrp="1"/>
+          </p:cNvSpPr>
+          <p:nvPr>
+            <p:ph type="body" idx="3" sz="quarter"/>
+          </p:nvPr>
+        </p:nvSpPr>
+        <p:spPr/>
+        <p:txBody>
+          <a:bodyPr/>
+          <a:lstStyle/>
+          <a:p>
+            <a:r>
+              <a:t>Mentor review summary: 01. System Context — Overview. Use this diagram to explain the actors/components, the direction of the flow, the CAP/backend control boundary, and the observable data or side effect. Canonical source asset: 01-system-context.png; editable source and manifest are kept in docs/diagrams/rendered.</a:t>
+            </a:r>
+          </a:p>
+        </p:txBody>
+      </p:sp>
+      <p:sp>
+        <p:nvSpPr>
+          <p:cNvPr id="4" name="Slide Number Placeholder 3"/>
+          <p:cNvSpPr>
+            <a:spLocks noGrp="1"/>
+          </p:cNvSpPr>
+          <p:nvPr>
+            <p:ph type="sldNum" idx="5" sz="quarter"/>
+          </p:nvPr>
+        </p:nvSpPr>
+        <p:spPr/>
+      </p:sp>
+    </p:spTree>
+  </p:cSld>
+  <p:clrMapOvr>
+    <a:masterClrMapping/>
+  </p:clrMapOvr>
+</p:notes>
+</file>
+
+<file path=ppt/notesSlides/notesSlide10.xml><?xml version="1.0" encoding="utf-8"?>
+<p:notes xmlns:a="http://schemas.openxmlformats.org/drawingml/2006/main" xmlns:p="http://schemas.openxmlformats.org/presentationml/2006/main" xmlns:r="http://schemas.openxmlformats.org/officeDocument/2006/relationships">
+  <p:cSld>
+    <p:spTree>
+      <p:nvGrpSpPr>
+        <p:cNvPr id="1" name=""/>
+        <p:cNvGrpSpPr/>
+        <p:nvPr/>
+      </p:nvGrpSpPr>
+      <p:grpSpPr>
+        <a:xfrm>
+          <a:off x="0" y="0"/>
+          <a:ext cx="0" cy="0"/>
+          <a:chOff x="0" y="0"/>
+          <a:chExt cx="0" cy="0"/>
+        </a:xfrm>
+      </p:grpSpPr>
+      <p:sp>
+        <p:nvSpPr>
+          <p:cNvPr id="2" name="Slide Image Placeholder 1"/>
+          <p:cNvSpPr>
+            <a:spLocks noGrp="1"/>
+          </p:cNvSpPr>
+          <p:nvPr>
+            <p:ph type="sldImg" idx="2"/>
+          </p:nvPr>
+        </p:nvSpPr>
+        <p:spPr/>
+      </p:sp>
+      <p:sp>
+        <p:nvSpPr>
+          <p:cNvPr id="3" name="Notes Placeholder 2"/>
+          <p:cNvSpPr>
+            <a:spLocks noGrp="1"/>
+          </p:cNvSpPr>
+          <p:nvPr>
+            <p:ph type="body" idx="3" sz="quarter"/>
+          </p:nvPr>
+        </p:nvSpPr>
+        <p:spPr/>
+        <p:txBody>
+          <a:bodyPr/>
+          <a:lstStyle/>
+          <a:p>
+            <a:r>
+              <a:t>Mentor review summary: 04. End-to-End Defect Tracking Flow — Detail 3/3. Use this diagram to explain the actors/components, the direction of the flow, the CAP/backend control boundary, and the observable data or side effect. Canonical source asset: 04-end-to-end-defect-flow.png; editable source and manifest are kept in docs/diagrams/rendered.</a:t>
+            </a:r>
+          </a:p>
+        </p:txBody>
+      </p:sp>
+      <p:sp>
+        <p:nvSpPr>
+          <p:cNvPr id="4" name="Slide Number Placeholder 3"/>
+          <p:cNvSpPr>
+            <a:spLocks noGrp="1"/>
+          </p:cNvSpPr>
+          <p:nvPr>
+            <p:ph type="sldNum" idx="5" sz="quarter"/>
+          </p:nvPr>
+        </p:nvSpPr>
+        <p:spPr/>
+      </p:sp>
+    </p:spTree>
+  </p:cSld>
+  <p:clrMapOvr>
+    <a:masterClrMapping/>
+  </p:clrMapOvr>
+</p:notes>
+</file>
+
+<file path=ppt/notesSlides/notesSlide11.xml><?xml version="1.0" encoding="utf-8"?>
+<p:notes xmlns:a="http://schemas.openxmlformats.org/drawingml/2006/main" xmlns:p="http://schemas.openxmlformats.org/presentationml/2006/main" xmlns:r="http://schemas.openxmlformats.org/officeDocument/2006/relationships">
+  <p:cSld>
+    <p:spTree>
+      <p:nvGrpSpPr>
+        <p:cNvPr id="1" name=""/>
+        <p:cNvGrpSpPr/>
+        <p:nvPr/>
+      </p:nvGrpSpPr>
+      <p:grpSpPr>
+        <a:xfrm>
+          <a:off x="0" y="0"/>
+          <a:ext cx="0" cy="0"/>
+          <a:chOff x="0" y="0"/>
+          <a:chExt cx="0" cy="0"/>
+        </a:xfrm>
+      </p:grpSpPr>
+      <p:sp>
+        <p:nvSpPr>
+          <p:cNvPr id="2" name="Slide Image Placeholder 1"/>
+          <p:cNvSpPr>
+            <a:spLocks noGrp="1"/>
+          </p:cNvSpPr>
+          <p:nvPr>
+            <p:ph type="sldImg" idx="2"/>
+          </p:nvPr>
+        </p:nvSpPr>
+        <p:spPr/>
+      </p:sp>
+      <p:sp>
+        <p:nvSpPr>
+          <p:cNvPr id="3" name="Notes Placeholder 2"/>
+          <p:cNvSpPr>
+            <a:spLocks noGrp="1"/>
+          </p:cNvSpPr>
+          <p:nvPr>
+            <p:ph type="body" idx="3" sz="quarter"/>
+          </p:nvPr>
+        </p:nvSpPr>
+        <p:spPr/>
+        <p:txBody>
+          <a:bodyPr/>
+          <a:lstStyle/>
+          <a:p>
+            <a:r>
+              <a:t>Mentor review summary: 05. Duplicate Checking Flow — Overview. Use this diagram to explain the actors/components, the direction of the flow, the CAP/backend control boundary, and the observable data or side effect. Canonical source asset: 05-duplicate-checking.png; editable source and manifest are kept in docs/diagrams/rendered.</a:t>
+            </a:r>
+          </a:p>
+        </p:txBody>
+      </p:sp>
+      <p:sp>
+        <p:nvSpPr>
+          <p:cNvPr id="4" name="Slide Number Placeholder 3"/>
+          <p:cNvSpPr>
+            <a:spLocks noGrp="1"/>
+          </p:cNvSpPr>
+          <p:nvPr>
+            <p:ph type="sldNum" idx="5" sz="quarter"/>
+          </p:nvPr>
+        </p:nvSpPr>
+        <p:spPr/>
+      </p:sp>
+    </p:spTree>
+  </p:cSld>
+  <p:clrMapOvr>
+    <a:masterClrMapping/>
+  </p:clrMapOvr>
+</p:notes>
+</file>
+
+<file path=ppt/notesSlides/notesSlide12.xml><?xml version="1.0" encoding="utf-8"?>
+<p:notes xmlns:a="http://schemas.openxmlformats.org/drawingml/2006/main" xmlns:p="http://schemas.openxmlformats.org/presentationml/2006/main" xmlns:r="http://schemas.openxmlformats.org/officeDocument/2006/relationships">
+  <p:cSld>
+    <p:spTree>
+      <p:nvGrpSpPr>
+        <p:cNvPr id="1" name=""/>
+        <p:cNvGrpSpPr/>
+        <p:nvPr/>
+      </p:nvGrpSpPr>
+      <p:grpSpPr>
+        <a:xfrm>
+          <a:off x="0" y="0"/>
+          <a:ext cx="0" cy="0"/>
+          <a:chOff x="0" y="0"/>
+          <a:chExt cx="0" cy="0"/>
+        </a:xfrm>
+      </p:grpSpPr>
+      <p:sp>
+        <p:nvSpPr>
+          <p:cNvPr id="2" name="Slide Image Placeholder 1"/>
+          <p:cNvSpPr>
+            <a:spLocks noGrp="1"/>
+          </p:cNvSpPr>
+          <p:nvPr>
+            <p:ph type="sldImg" idx="2"/>
+          </p:nvPr>
+        </p:nvSpPr>
+        <p:spPr/>
+      </p:sp>
+      <p:sp>
+        <p:nvSpPr>
+          <p:cNvPr id="3" name="Notes Placeholder 2"/>
+          <p:cNvSpPr>
+            <a:spLocks noGrp="1"/>
+          </p:cNvSpPr>
+          <p:nvPr>
+            <p:ph type="body" idx="3" sz="quarter"/>
+          </p:nvPr>
+        </p:nvSpPr>
+        <p:spPr/>
+        <p:txBody>
+          <a:bodyPr/>
+          <a:lstStyle/>
+          <a:p>
+            <a:r>
+              <a:t>Mentor review summary: 06. Assignment Decision Flow — Overview. Use this diagram to explain the actors/components, the direction of the flow, the CAP/backend control boundary, and the observable data or side effect. Canonical source asset: 06-assignment-decision.png; editable source and manifest are kept in docs/diagrams/rendered.</a:t>
+            </a:r>
+          </a:p>
+        </p:txBody>
+      </p:sp>
+      <p:sp>
+        <p:nvSpPr>
+          <p:cNvPr id="4" name="Slide Number Placeholder 3"/>
+          <p:cNvSpPr>
+            <a:spLocks noGrp="1"/>
+          </p:cNvSpPr>
+          <p:nvPr>
+            <p:ph type="sldNum" idx="5" sz="quarter"/>
+          </p:nvPr>
+        </p:nvSpPr>
+        <p:spPr/>
+      </p:sp>
+    </p:spTree>
+  </p:cSld>
+  <p:clrMapOvr>
+    <a:masterClrMapping/>
+  </p:clrMapOvr>
+</p:notes>
+</file>
+
+<file path=ppt/notesSlides/notesSlide13.xml><?xml version="1.0" encoding="utf-8"?>
+<p:notes xmlns:a="http://schemas.openxmlformats.org/drawingml/2006/main" xmlns:p="http://schemas.openxmlformats.org/presentationml/2006/main" xmlns:r="http://schemas.openxmlformats.org/officeDocument/2006/relationships">
+  <p:cSld>
+    <p:spTree>
+      <p:nvGrpSpPr>
+        <p:cNvPr id="1" name=""/>
+        <p:cNvGrpSpPr/>
+        <p:nvPr/>
+      </p:nvGrpSpPr>
+      <p:grpSpPr>
+        <a:xfrm>
+          <a:off x="0" y="0"/>
+          <a:ext cx="0" cy="0"/>
+          <a:chOff x="0" y="0"/>
+          <a:chExt cx="0" cy="0"/>
+        </a:xfrm>
+      </p:grpSpPr>
+      <p:sp>
+        <p:nvSpPr>
+          <p:cNvPr id="2" name="Slide Image Placeholder 1"/>
+          <p:cNvSpPr>
+            <a:spLocks noGrp="1"/>
+          </p:cNvSpPr>
+          <p:nvPr>
+            <p:ph type="sldImg" idx="2"/>
+          </p:nvPr>
+        </p:nvSpPr>
+        <p:spPr/>
+      </p:sp>
+      <p:sp>
+        <p:nvSpPr>
+          <p:cNvPr id="3" name="Notes Placeholder 2"/>
+          <p:cNvSpPr>
+            <a:spLocks noGrp="1"/>
+          </p:cNvSpPr>
+          <p:nvPr>
+            <p:ph type="body" idx="3" sz="quarter"/>
+          </p:nvPr>
+        </p:nvSpPr>
+        <p:spPr/>
+        <p:txBody>
+          <a:bodyPr/>
+          <a:lstStyle/>
+          <a:p>
+            <a:r>
+              <a:t>Mentor review summary: 06. Assignment Decision Flow — Detail 1/3. Use this diagram to explain the actors/components, the direction of the flow, the CAP/backend control boundary, and the observable data or side effect. Canonical source asset: 06-assignment-decision.png; editable source and manifest are kept in docs/diagrams/rendered.</a:t>
+            </a:r>
+          </a:p>
+        </p:txBody>
+      </p:sp>
+      <p:sp>
+        <p:nvSpPr>
+          <p:cNvPr id="4" name="Slide Number Placeholder 3"/>
+          <p:cNvSpPr>
+            <a:spLocks noGrp="1"/>
+          </p:cNvSpPr>
+          <p:nvPr>
+            <p:ph type="sldNum" idx="5" sz="quarter"/>
+          </p:nvPr>
+        </p:nvSpPr>
+        <p:spPr/>
+      </p:sp>
+    </p:spTree>
+  </p:cSld>
+  <p:clrMapOvr>
+    <a:masterClrMapping/>
+  </p:clrMapOvr>
+</p:notes>
+</file>
+
+<file path=ppt/notesSlides/notesSlide14.xml><?xml version="1.0" encoding="utf-8"?>
+<p:notes xmlns:a="http://schemas.openxmlformats.org/drawingml/2006/main" xmlns:p="http://schemas.openxmlformats.org/presentationml/2006/main" xmlns:r="http://schemas.openxmlformats.org/officeDocument/2006/relationships">
+  <p:cSld>
+    <p:spTree>
+      <p:nvGrpSpPr>
+        <p:cNvPr id="1" name=""/>
+        <p:cNvGrpSpPr/>
+        <p:nvPr/>
+      </p:nvGrpSpPr>
+      <p:grpSpPr>
+        <a:xfrm>
+          <a:off x="0" y="0"/>
+          <a:ext cx="0" cy="0"/>
+          <a:chOff x="0" y="0"/>
+          <a:chExt cx="0" cy="0"/>
+        </a:xfrm>
+      </p:grpSpPr>
+      <p:sp>
+        <p:nvSpPr>
+          <p:cNvPr id="2" name="Slide Image Placeholder 1"/>
+          <p:cNvSpPr>
+            <a:spLocks noGrp="1"/>
+          </p:cNvSpPr>
+          <p:nvPr>
+            <p:ph type="sldImg" idx="2"/>
+          </p:nvPr>
+        </p:nvSpPr>
+        <p:spPr/>
+      </p:sp>
+      <p:sp>
+        <p:nvSpPr>
+          <p:cNvPr id="3" name="Notes Placeholder 2"/>
+          <p:cNvSpPr>
+            <a:spLocks noGrp="1"/>
+          </p:cNvSpPr>
+          <p:nvPr>
+            <p:ph type="body" idx="3" sz="quarter"/>
+          </p:nvPr>
+        </p:nvSpPr>
+        <p:spPr/>
+        <p:txBody>
+          <a:bodyPr/>
+          <a:lstStyle/>
+          <a:p>
+            <a:r>
+              <a:t>Mentor review summary: 06. Assignment Decision Flow — Detail 2/3. Use this diagram to explain the actors/components, the direction of the flow, the CAP/backend control boundary, and the observable data or side effect. Canonical source asset: 06-assignment-decision.png; editable source and manifest are kept in docs/diagrams/rendered.</a:t>
+            </a:r>
+          </a:p>
+        </p:txBody>
+      </p:sp>
+      <p:sp>
+        <p:nvSpPr>
+          <p:cNvPr id="4" name="Slide Number Placeholder 3"/>
+          <p:cNvSpPr>
+            <a:spLocks noGrp="1"/>
+          </p:cNvSpPr>
+          <p:nvPr>
+            <p:ph type="sldNum" idx="5" sz="quarter"/>
+          </p:nvPr>
+        </p:nvSpPr>
+        <p:spPr/>
+      </p:sp>
+    </p:spTree>
+  </p:cSld>
+  <p:clrMapOvr>
+    <a:masterClrMapping/>
+  </p:clrMapOvr>
+</p:notes>
+</file>
+
+<file path=ppt/notesSlides/notesSlide15.xml><?xml version="1.0" encoding="utf-8"?>
+<p:notes xmlns:a="http://schemas.openxmlformats.org/drawingml/2006/main" xmlns:p="http://schemas.openxmlformats.org/presentationml/2006/main" xmlns:r="http://schemas.openxmlformats.org/officeDocument/2006/relationships">
+  <p:cSld>
+    <p:spTree>
+      <p:nvGrpSpPr>
+        <p:cNvPr id="1" name=""/>
+        <p:cNvGrpSpPr/>
+        <p:nvPr/>
+      </p:nvGrpSpPr>
+      <p:grpSpPr>
+        <a:xfrm>
+          <a:off x="0" y="0"/>
+          <a:ext cx="0" cy="0"/>
+          <a:chOff x="0" y="0"/>
+          <a:chExt cx="0" cy="0"/>
+        </a:xfrm>
+      </p:grpSpPr>
+      <p:sp>
+        <p:nvSpPr>
+          <p:cNvPr id="2" name="Slide Image Placeholder 1"/>
+          <p:cNvSpPr>
+            <a:spLocks noGrp="1"/>
+          </p:cNvSpPr>
+          <p:nvPr>
+            <p:ph type="sldImg" idx="2"/>
+          </p:nvPr>
+        </p:nvSpPr>
+        <p:spPr/>
+      </p:sp>
+      <p:sp>
+        <p:nvSpPr>
+          <p:cNvPr id="3" name="Notes Placeholder 2"/>
+          <p:cNvSpPr>
+            <a:spLocks noGrp="1"/>
+          </p:cNvSpPr>
+          <p:nvPr>
+            <p:ph type="body" idx="3" sz="quarter"/>
+          </p:nvPr>
+        </p:nvSpPr>
+        <p:spPr/>
+        <p:txBody>
+          <a:bodyPr/>
+          <a:lstStyle/>
+          <a:p>
+            <a:r>
+              <a:t>Mentor review summary: 06. Assignment Decision Flow — Detail 3/3. Use this diagram to explain the actors/components, the direction of the flow, the CAP/backend control boundary, and the observable data or side effect. Canonical source asset: 06-assignment-decision.png; editable source and manifest are kept in docs/diagrams/rendered.</a:t>
+            </a:r>
+          </a:p>
+        </p:txBody>
+      </p:sp>
+      <p:sp>
+        <p:nvSpPr>
+          <p:cNvPr id="4" name="Slide Number Placeholder 3"/>
+          <p:cNvSpPr>
+            <a:spLocks noGrp="1"/>
+          </p:cNvSpPr>
+          <p:nvPr>
+            <p:ph type="sldNum" idx="5" sz="quarter"/>
+          </p:nvPr>
+        </p:nvSpPr>
+        <p:spPr/>
+      </p:sp>
+    </p:spTree>
+  </p:cSld>
+  <p:clrMapOvr>
+    <a:masterClrMapping/>
+  </p:clrMapOvr>
+</p:notes>
+</file>
+
+<file path=ppt/notesSlides/notesSlide16.xml><?xml version="1.0" encoding="utf-8"?>
+<p:notes xmlns:a="http://schemas.openxmlformats.org/drawingml/2006/main" xmlns:p="http://schemas.openxmlformats.org/presentationml/2006/main" xmlns:r="http://schemas.openxmlformats.org/officeDocument/2006/relationships">
+  <p:cSld>
+    <p:spTree>
+      <p:nvGrpSpPr>
+        <p:cNvPr id="1" name=""/>
+        <p:cNvGrpSpPr/>
+        <p:nvPr/>
+      </p:nvGrpSpPr>
+      <p:grpSpPr>
+        <a:xfrm>
+          <a:off x="0" y="0"/>
+          <a:ext cx="0" cy="0"/>
+          <a:chOff x="0" y="0"/>
+          <a:chExt cx="0" cy="0"/>
+        </a:xfrm>
+      </p:grpSpPr>
+      <p:sp>
+        <p:nvSpPr>
+          <p:cNvPr id="2" name="Slide Image Placeholder 1"/>
+          <p:cNvSpPr>
+            <a:spLocks noGrp="1"/>
+          </p:cNvSpPr>
+          <p:nvPr>
+            <p:ph type="sldImg" idx="2"/>
+          </p:nvPr>
+        </p:nvSpPr>
+        <p:spPr/>
+      </p:sp>
+      <p:sp>
+        <p:nvSpPr>
+          <p:cNvPr id="3" name="Notes Placeholder 2"/>
+          <p:cNvSpPr>
+            <a:spLocks noGrp="1"/>
+          </p:cNvSpPr>
+          <p:nvPr>
+            <p:ph type="body" idx="3" sz="quarter"/>
+          </p:nvPr>
+        </p:nvSpPr>
+        <p:spPr/>
+        <p:txBody>
+          <a:bodyPr/>
+          <a:lstStyle/>
+          <a:p>
+            <a:r>
+              <a:t>Mentor review summary: 07. Developer Review Flow — Overview. Use this diagram to explain the actors/components, the direction of the flow, the CAP/backend control boundary, and the observable data or side effect. Canonical source asset: 07-developer-review.png; editable source and manifest are kept in docs/diagrams/rendered.</a:t>
+            </a:r>
+          </a:p>
+        </p:txBody>
+      </p:sp>
+      <p:sp>
+        <p:nvSpPr>
+          <p:cNvPr id="4" name="Slide Number Placeholder 3"/>
+          <p:cNvSpPr>
+            <a:spLocks noGrp="1"/>
+          </p:cNvSpPr>
+          <p:nvPr>
+            <p:ph type="sldNum" idx="5" sz="quarter"/>
+          </p:nvPr>
+        </p:nvSpPr>
+        <p:spPr/>
+      </p:sp>
+    </p:spTree>
+  </p:cSld>
+  <p:clrMapOvr>
+    <a:masterClrMapping/>
+  </p:clrMapOvr>
+</p:notes>
+</file>
+
+<file path=ppt/notesSlides/notesSlide17.xml><?xml version="1.0" encoding="utf-8"?>
+<p:notes xmlns:a="http://schemas.openxmlformats.org/drawingml/2006/main" xmlns:p="http://schemas.openxmlformats.org/presentationml/2006/main" xmlns:r="http://schemas.openxmlformats.org/officeDocument/2006/relationships">
+  <p:cSld>
+    <p:spTree>
+      <p:nvGrpSpPr>
+        <p:cNvPr id="1" name=""/>
+        <p:cNvGrpSpPr/>
+        <p:nvPr/>
+      </p:nvGrpSpPr>
+      <p:grpSpPr>
+        <a:xfrm>
+          <a:off x="0" y="0"/>
+          <a:ext cx="0" cy="0"/>
+          <a:chOff x="0" y="0"/>
+          <a:chExt cx="0" cy="0"/>
+        </a:xfrm>
+      </p:grpSpPr>
+      <p:sp>
+        <p:nvSpPr>
+          <p:cNvPr id="2" name="Slide Image Placeholder 1"/>
+          <p:cNvSpPr>
+            <a:spLocks noGrp="1"/>
+          </p:cNvSpPr>
+          <p:nvPr>
+            <p:ph type="sldImg" idx="2"/>
+          </p:nvPr>
+        </p:nvSpPr>
+        <p:spPr/>
+      </p:sp>
+      <p:sp>
+        <p:nvSpPr>
+          <p:cNvPr id="3" name="Notes Placeholder 2"/>
+          <p:cNvSpPr>
+            <a:spLocks noGrp="1"/>
+          </p:cNvSpPr>
+          <p:nvPr>
+            <p:ph type="body" idx="3" sz="quarter"/>
+          </p:nvPr>
+        </p:nvSpPr>
+        <p:spPr/>
+        <p:txBody>
+          <a:bodyPr/>
+          <a:lstStyle/>
+          <a:p>
+            <a:r>
+              <a:t>Mentor review summary: 08. Bug Status Lifecycle — Overview. Use this diagram to explain the actors/components, the direction of the flow, the CAP/backend control boundary, and the observable data or side effect. Canonical source asset: 08-status-lifecycle.png; editable source and manifest are kept in docs/diagrams/rendered.</a:t>
+            </a:r>
+          </a:p>
+        </p:txBody>
+      </p:sp>
+      <p:sp>
+        <p:nvSpPr>
+          <p:cNvPr id="4" name="Slide Number Placeholder 3"/>
+          <p:cNvSpPr>
+            <a:spLocks noGrp="1"/>
+          </p:cNvSpPr>
+          <p:nvPr>
+            <p:ph type="sldNum" idx="5" sz="quarter"/>
+          </p:nvPr>
+        </p:nvSpPr>
+        <p:spPr/>
+      </p:sp>
+    </p:spTree>
+  </p:cSld>
+  <p:clrMapOvr>
+    <a:masterClrMapping/>
+  </p:clrMapOvr>
+</p:notes>
+</file>
+
+<file path=ppt/notesSlides/notesSlide18.xml><?xml version="1.0" encoding="utf-8"?>
+<p:notes xmlns:a="http://schemas.openxmlformats.org/drawingml/2006/main" xmlns:p="http://schemas.openxmlformats.org/presentationml/2006/main" xmlns:r="http://schemas.openxmlformats.org/officeDocument/2006/relationships">
+  <p:cSld>
+    <p:spTree>
+      <p:nvGrpSpPr>
+        <p:cNvPr id="1" name=""/>
+        <p:cNvGrpSpPr/>
+        <p:nvPr/>
+      </p:nvGrpSpPr>
+      <p:grpSpPr>
+        <a:xfrm>
+          <a:off x="0" y="0"/>
+          <a:ext cx="0" cy="0"/>
+          <a:chOff x="0" y="0"/>
+          <a:chExt cx="0" cy="0"/>
+        </a:xfrm>
+      </p:grpSpPr>
+      <p:sp>
+        <p:nvSpPr>
+          <p:cNvPr id="2" name="Slide Image Placeholder 1"/>
+          <p:cNvSpPr>
+            <a:spLocks noGrp="1"/>
+          </p:cNvSpPr>
+          <p:nvPr>
+            <p:ph type="sldImg" idx="2"/>
+          </p:nvPr>
+        </p:nvSpPr>
+        <p:spPr/>
+      </p:sp>
+      <p:sp>
+        <p:nvSpPr>
+          <p:cNvPr id="3" name="Notes Placeholder 2"/>
+          <p:cNvSpPr>
+            <a:spLocks noGrp="1"/>
+          </p:cNvSpPr>
+          <p:nvPr>
+            <p:ph type="body" idx="3" sz="quarter"/>
+          </p:nvPr>
+        </p:nvSpPr>
+        <p:spPr/>
+        <p:txBody>
+          <a:bodyPr/>
+          <a:lstStyle/>
+          <a:p>
+            <a:r>
+              <a:t>Mentor review summary: 08. Bug Status Lifecycle — Detail 1/2. Use this diagram to explain the actors/components, the direction of the flow, the CAP/backend control boundary, and the observable data or side effect. Canonical source asset: 08-status-lifecycle.png; editable source and manifest are kept in docs/diagrams/rendered.</a:t>
+            </a:r>
+          </a:p>
+        </p:txBody>
+      </p:sp>
+      <p:sp>
+        <p:nvSpPr>
+          <p:cNvPr id="4" name="Slide Number Placeholder 3"/>
+          <p:cNvSpPr>
+            <a:spLocks noGrp="1"/>
+          </p:cNvSpPr>
+          <p:nvPr>
+            <p:ph type="sldNum" idx="5" sz="quarter"/>
+          </p:nvPr>
+        </p:nvSpPr>
+        <p:spPr/>
+      </p:sp>
+    </p:spTree>
+  </p:cSld>
+  <p:clrMapOvr>
+    <a:masterClrMapping/>
+  </p:clrMapOvr>
+</p:notes>
+</file>
+
+<file path=ppt/notesSlides/notesSlide19.xml><?xml version="1.0" encoding="utf-8"?>
+<p:notes xmlns:a="http://schemas.openxmlformats.org/drawingml/2006/main" xmlns:p="http://schemas.openxmlformats.org/presentationml/2006/main" xmlns:r="http://schemas.openxmlformats.org/officeDocument/2006/relationships">
+  <p:cSld>
+    <p:spTree>
+      <p:nvGrpSpPr>
+        <p:cNvPr id="1" name=""/>
+        <p:cNvGrpSpPr/>
+        <p:nvPr/>
+      </p:nvGrpSpPr>
+      <p:grpSpPr>
+        <a:xfrm>
+          <a:off x="0" y="0"/>
+          <a:ext cx="0" cy="0"/>
+          <a:chOff x="0" y="0"/>
+          <a:chExt cx="0" cy="0"/>
+        </a:xfrm>
+      </p:grpSpPr>
+      <p:sp>
+        <p:nvSpPr>
+          <p:cNvPr id="2" name="Slide Image Placeholder 1"/>
+          <p:cNvSpPr>
+            <a:spLocks noGrp="1"/>
+          </p:cNvSpPr>
+          <p:nvPr>
+            <p:ph type="sldImg" idx="2"/>
+          </p:nvPr>
+        </p:nvSpPr>
+        <p:spPr/>
+      </p:sp>
+      <p:sp>
+        <p:nvSpPr>
+          <p:cNvPr id="3" name="Notes Placeholder 2"/>
+          <p:cNvSpPr>
+            <a:spLocks noGrp="1"/>
+          </p:cNvSpPr>
+          <p:nvPr>
+            <p:ph type="body" idx="3" sz="quarter"/>
+          </p:nvPr>
+        </p:nvSpPr>
+        <p:spPr/>
+        <p:txBody>
+          <a:bodyPr/>
+          <a:lstStyle/>
+          <a:p>
+            <a:r>
+              <a:t>Mentor review summary: 08. Bug Status Lifecycle — Detail 2/2. Use this diagram to explain the actors/components, the direction of the flow, the CAP/backend control boundary, and the observable data or side effect. Canonical source asset: 08-status-lifecycle.png; editable source and manifest are kept in docs/diagrams/rendered.</a:t>
+            </a:r>
+          </a:p>
+        </p:txBody>
+      </p:sp>
+      <p:sp>
+        <p:nvSpPr>
+          <p:cNvPr id="4" name="Slide Number Placeholder 3"/>
+          <p:cNvSpPr>
+            <a:spLocks noGrp="1"/>
+          </p:cNvSpPr>
+          <p:nvPr>
+            <p:ph type="sldNum" idx="5" sz="quarter"/>
+          </p:nvPr>
+        </p:nvSpPr>
+        <p:spPr/>
+      </p:sp>
+    </p:spTree>
+  </p:cSld>
+  <p:clrMapOvr>
+    <a:masterClrMapping/>
+  </p:clrMapOvr>
+</p:notes>
+</file>
+
+<file path=ppt/notesSlides/notesSlide2.xml><?xml version="1.0" encoding="utf-8"?>
+<p:notes xmlns:a="http://schemas.openxmlformats.org/drawingml/2006/main" xmlns:p="http://schemas.openxmlformats.org/presentationml/2006/main" xmlns:r="http://schemas.openxmlformats.org/officeDocument/2006/relationships">
+  <p:cSld>
+    <p:spTree>
+      <p:nvGrpSpPr>
+        <p:cNvPr id="1" name=""/>
+        <p:cNvGrpSpPr/>
+        <p:nvPr/>
+      </p:nvGrpSpPr>
+      <p:grpSpPr>
+        <a:xfrm>
+          <a:off x="0" y="0"/>
+          <a:ext cx="0" cy="0"/>
+          <a:chOff x="0" y="0"/>
+          <a:chExt cx="0" cy="0"/>
+        </a:xfrm>
+      </p:grpSpPr>
+      <p:sp>
+        <p:nvSpPr>
+          <p:cNvPr id="2" name="Slide Image Placeholder 1"/>
+          <p:cNvSpPr>
+            <a:spLocks noGrp="1"/>
+          </p:cNvSpPr>
+          <p:nvPr>
+            <p:ph type="sldImg" idx="2"/>
+          </p:nvPr>
+        </p:nvSpPr>
+        <p:spPr/>
+      </p:sp>
+      <p:sp>
+        <p:nvSpPr>
+          <p:cNvPr id="3" name="Notes Placeholder 2"/>
+          <p:cNvSpPr>
+            <a:spLocks noGrp="1"/>
+          </p:cNvSpPr>
+          <p:nvPr>
+            <p:ph type="body" idx="3" sz="quarter"/>
+          </p:nvPr>
+        </p:nvSpPr>
+        <p:spPr/>
+        <p:txBody>
+          <a:bodyPr/>
+          <a:lstStyle/>
+          <a:p>
+            <a:r>
+              <a:t>Mentor review summary: 02. SAP CAP/Fiori Architecture — Overview. Use this diagram to explain the actors/components, the direction of the flow, the CAP/backend control boundary, and the observable data or side effect. Canonical source asset: 02-cap-fiori-architecture.png; editable source and manifest are kept in docs/diagrams/rendered.</a:t>
+            </a:r>
+          </a:p>
+        </p:txBody>
+      </p:sp>
+      <p:sp>
+        <p:nvSpPr>
+          <p:cNvPr id="4" name="Slide Number Placeholder 3"/>
+          <p:cNvSpPr>
+            <a:spLocks noGrp="1"/>
+          </p:cNvSpPr>
+          <p:nvPr>
+            <p:ph type="sldNum" idx="5" sz="quarter"/>
+          </p:nvPr>
+        </p:nvSpPr>
+        <p:spPr/>
+      </p:sp>
+    </p:spTree>
+  </p:cSld>
+  <p:clrMapOvr>
+    <a:masterClrMapping/>
+  </p:clrMapOvr>
+</p:notes>
+</file>
+
+<file path=ppt/notesSlides/notesSlide20.xml><?xml version="1.0" encoding="utf-8"?>
+<p:notes xmlns:a="http://schemas.openxmlformats.org/drawingml/2006/main" xmlns:p="http://schemas.openxmlformats.org/presentationml/2006/main" xmlns:r="http://schemas.openxmlformats.org/officeDocument/2006/relationships">
+  <p:cSld>
+    <p:spTree>
+      <p:nvGrpSpPr>
+        <p:cNvPr id="1" name=""/>
+        <p:cNvGrpSpPr/>
+        <p:nvPr/>
+      </p:nvGrpSpPr>
+      <p:grpSpPr>
+        <a:xfrm>
+          <a:off x="0" y="0"/>
+          <a:ext cx="0" cy="0"/>
+          <a:chOff x="0" y="0"/>
+          <a:chExt cx="0" cy="0"/>
+        </a:xfrm>
+      </p:grpSpPr>
+      <p:sp>
+        <p:nvSpPr>
+          <p:cNvPr id="2" name="Slide Image Placeholder 1"/>
+          <p:cNvSpPr>
+            <a:spLocks noGrp="1"/>
+          </p:cNvSpPr>
+          <p:nvPr>
+            <p:ph type="sldImg" idx="2"/>
+          </p:nvPr>
+        </p:nvSpPr>
+        <p:spPr/>
+      </p:sp>
+      <p:sp>
+        <p:nvSpPr>
+          <p:cNvPr id="3" name="Notes Placeholder 2"/>
+          <p:cNvSpPr>
+            <a:spLocks noGrp="1"/>
+          </p:cNvSpPr>
+          <p:nvPr>
+            <p:ph type="body" idx="3" sz="quarter"/>
+          </p:nvPr>
+        </p:nvSpPr>
+        <p:spPr/>
+        <p:txBody>
+          <a:bodyPr/>
+          <a:lstStyle/>
+          <a:p>
+            <a:r>
+              <a:t>Mentor review summary: 09. Conceptual Data Model — Overview. Use this diagram to explain the actors/components, the direction of the flow, the CAP/backend control boundary, and the observable data or side effect. Canonical source asset: 09-conceptual-data-model.png; editable source and manifest are kept in docs/diagrams/rendered.</a:t>
+            </a:r>
+          </a:p>
+        </p:txBody>
+      </p:sp>
+      <p:sp>
+        <p:nvSpPr>
+          <p:cNvPr id="4" name="Slide Number Placeholder 3"/>
+          <p:cNvSpPr>
+            <a:spLocks noGrp="1"/>
+          </p:cNvSpPr>
+          <p:nvPr>
+            <p:ph type="sldNum" idx="5" sz="quarter"/>
+          </p:nvPr>
+        </p:nvSpPr>
+        <p:spPr/>
+      </p:sp>
+    </p:spTree>
+  </p:cSld>
+  <p:clrMapOvr>
+    <a:masterClrMapping/>
+  </p:clrMapOvr>
+</p:notes>
+</file>
+
+<file path=ppt/notesSlides/notesSlide21.xml><?xml version="1.0" encoding="utf-8"?>
+<p:notes xmlns:a="http://schemas.openxmlformats.org/drawingml/2006/main" xmlns:p="http://schemas.openxmlformats.org/presentationml/2006/main" xmlns:r="http://schemas.openxmlformats.org/officeDocument/2006/relationships">
+  <p:cSld>
+    <p:spTree>
+      <p:nvGrpSpPr>
+        <p:cNvPr id="1" name=""/>
+        <p:cNvGrpSpPr/>
+        <p:nvPr/>
+      </p:nvGrpSpPr>
+      <p:grpSpPr>
+        <a:xfrm>
+          <a:off x="0" y="0"/>
+          <a:ext cx="0" cy="0"/>
+          <a:chOff x="0" y="0"/>
+          <a:chExt cx="0" cy="0"/>
+        </a:xfrm>
+      </p:grpSpPr>
+      <p:sp>
+        <p:nvSpPr>
+          <p:cNvPr id="2" name="Slide Image Placeholder 1"/>
+          <p:cNvSpPr>
+            <a:spLocks noGrp="1"/>
+          </p:cNvSpPr>
+          <p:nvPr>
+            <p:ph type="sldImg" idx="2"/>
+          </p:nvPr>
+        </p:nvSpPr>
+        <p:spPr/>
+      </p:sp>
+      <p:sp>
+        <p:nvSpPr>
+          <p:cNvPr id="3" name="Notes Placeholder 2"/>
+          <p:cNvSpPr>
+            <a:spLocks noGrp="1"/>
+          </p:cNvSpPr>
+          <p:nvPr>
+            <p:ph type="body" idx="3" sz="quarter"/>
+          </p:nvPr>
+        </p:nvSpPr>
+        <p:spPr/>
+        <p:txBody>
+          <a:bodyPr/>
+          <a:lstStyle/>
+          <a:p>
+            <a:r>
+              <a:t>Mentor review summary: 09. Conceptual Data Model — Detail 1/4. Use this diagram to explain the actors/components, the direction of the flow, the CAP/backend control boundary, and the observable data or side effect. Canonical source asset: 09-conceptual-data-model.png; editable source and manifest are kept in docs/diagrams/rendered.</a:t>
+            </a:r>
+          </a:p>
+        </p:txBody>
+      </p:sp>
+      <p:sp>
+        <p:nvSpPr>
+          <p:cNvPr id="4" name="Slide Number Placeholder 3"/>
+          <p:cNvSpPr>
+            <a:spLocks noGrp="1"/>
+          </p:cNvSpPr>
+          <p:nvPr>
+            <p:ph type="sldNum" idx="5" sz="quarter"/>
+          </p:nvPr>
+        </p:nvSpPr>
+        <p:spPr/>
+      </p:sp>
+    </p:spTree>
+  </p:cSld>
+  <p:clrMapOvr>
+    <a:masterClrMapping/>
+  </p:clrMapOvr>
+</p:notes>
+</file>
+
+<file path=ppt/notesSlides/notesSlide22.xml><?xml version="1.0" encoding="utf-8"?>
+<p:notes xmlns:a="http://schemas.openxmlformats.org/drawingml/2006/main" xmlns:p="http://schemas.openxmlformats.org/presentationml/2006/main" xmlns:r="http://schemas.openxmlformats.org/officeDocument/2006/relationships">
+  <p:cSld>
+    <p:spTree>
+      <p:nvGrpSpPr>
+        <p:cNvPr id="1" name=""/>
+        <p:cNvGrpSpPr/>
+        <p:nvPr/>
+      </p:nvGrpSpPr>
+      <p:grpSpPr>
+        <a:xfrm>
+          <a:off x="0" y="0"/>
+          <a:ext cx="0" cy="0"/>
+          <a:chOff x="0" y="0"/>
+          <a:chExt cx="0" cy="0"/>
+        </a:xfrm>
+      </p:grpSpPr>
+      <p:sp>
+        <p:nvSpPr>
+          <p:cNvPr id="2" name="Slide Image Placeholder 1"/>
+          <p:cNvSpPr>
+            <a:spLocks noGrp="1"/>
+          </p:cNvSpPr>
+          <p:nvPr>
+            <p:ph type="sldImg" idx="2"/>
+          </p:nvPr>
+        </p:nvSpPr>
+        <p:spPr/>
+      </p:sp>
+      <p:sp>
+        <p:nvSpPr>
+          <p:cNvPr id="3" name="Notes Placeholder 2"/>
+          <p:cNvSpPr>
+            <a:spLocks noGrp="1"/>
+          </p:cNvSpPr>
+          <p:nvPr>
+            <p:ph type="body" idx="3" sz="quarter"/>
+          </p:nvPr>
+        </p:nvSpPr>
+        <p:spPr/>
+        <p:txBody>
+          <a:bodyPr/>
+          <a:lstStyle/>
+          <a:p>
+            <a:r>
+              <a:t>Mentor review summary: 09. Conceptual Data Model — Detail 2/4. Use this diagram to explain the actors/components, the direction of the flow, the CAP/backend control boundary, and the observable data or side effect. Canonical source asset: 09-conceptual-data-model.png; editable source and manifest are kept in docs/diagrams/rendered.</a:t>
+            </a:r>
+          </a:p>
+        </p:txBody>
+      </p:sp>
+      <p:sp>
+        <p:nvSpPr>
+          <p:cNvPr id="4" name="Slide Number Placeholder 3"/>
+          <p:cNvSpPr>
+            <a:spLocks noGrp="1"/>
+          </p:cNvSpPr>
+          <p:nvPr>
+            <p:ph type="sldNum" idx="5" sz="quarter"/>
+          </p:nvPr>
+        </p:nvSpPr>
+        <p:spPr/>
+      </p:sp>
+    </p:spTree>
+  </p:cSld>
+  <p:clrMapOvr>
+    <a:masterClrMapping/>
+  </p:clrMapOvr>
+</p:notes>
+</file>
+
+<file path=ppt/notesSlides/notesSlide23.xml><?xml version="1.0" encoding="utf-8"?>
+<p:notes xmlns:a="http://schemas.openxmlformats.org/drawingml/2006/main" xmlns:p="http://schemas.openxmlformats.org/presentationml/2006/main" xmlns:r="http://schemas.openxmlformats.org/officeDocument/2006/relationships">
+  <p:cSld>
+    <p:spTree>
+      <p:nvGrpSpPr>
+        <p:cNvPr id="1" name=""/>
+        <p:cNvGrpSpPr/>
+        <p:nvPr/>
+      </p:nvGrpSpPr>
+      <p:grpSpPr>
+        <a:xfrm>
+          <a:off x="0" y="0"/>
+          <a:ext cx="0" cy="0"/>
+          <a:chOff x="0" y="0"/>
+          <a:chExt cx="0" cy="0"/>
+        </a:xfrm>
+      </p:grpSpPr>
+      <p:sp>
+        <p:nvSpPr>
+          <p:cNvPr id="2" name="Slide Image Placeholder 1"/>
+          <p:cNvSpPr>
+            <a:spLocks noGrp="1"/>
+          </p:cNvSpPr>
+          <p:nvPr>
+            <p:ph type="sldImg" idx="2"/>
+          </p:nvPr>
+        </p:nvSpPr>
+        <p:spPr/>
+      </p:sp>
+      <p:sp>
+        <p:nvSpPr>
+          <p:cNvPr id="3" name="Notes Placeholder 2"/>
+          <p:cNvSpPr>
+            <a:spLocks noGrp="1"/>
+          </p:cNvSpPr>
+          <p:nvPr>
+            <p:ph type="body" idx="3" sz="quarter"/>
+          </p:nvPr>
+        </p:nvSpPr>
+        <p:spPr/>
+        <p:txBody>
+          <a:bodyPr/>
+          <a:lstStyle/>
+          <a:p>
+            <a:r>
+              <a:t>Mentor review summary: 09. Conceptual Data Model — Detail 3/4. Use this diagram to explain the actors/components, the direction of the flow, the CAP/backend control boundary, and the observable data or side effect. Canonical source asset: 09-conceptual-data-model.png; editable source and manifest are kept in docs/diagrams/rendered.</a:t>
+            </a:r>
+          </a:p>
+        </p:txBody>
+      </p:sp>
+      <p:sp>
+        <p:nvSpPr>
+          <p:cNvPr id="4" name="Slide Number Placeholder 3"/>
+          <p:cNvSpPr>
+            <a:spLocks noGrp="1"/>
+          </p:cNvSpPr>
+          <p:nvPr>
+            <p:ph type="sldNum" idx="5" sz="quarter"/>
+          </p:nvPr>
+        </p:nvSpPr>
+        <p:spPr/>
+      </p:sp>
+    </p:spTree>
+  </p:cSld>
+  <p:clrMapOvr>
+    <a:masterClrMapping/>
+  </p:clrMapOvr>
+</p:notes>
+</file>
+
+<file path=ppt/notesSlides/notesSlide24.xml><?xml version="1.0" encoding="utf-8"?>
+<p:notes xmlns:a="http://schemas.openxmlformats.org/drawingml/2006/main" xmlns:p="http://schemas.openxmlformats.org/presentationml/2006/main" xmlns:r="http://schemas.openxmlformats.org/officeDocument/2006/relationships">
+  <p:cSld>
+    <p:spTree>
+      <p:nvGrpSpPr>
+        <p:cNvPr id="1" name=""/>
+        <p:cNvGrpSpPr/>
+        <p:nvPr/>
+      </p:nvGrpSpPr>
+      <p:grpSpPr>
+        <a:xfrm>
+          <a:off x="0" y="0"/>
+          <a:ext cx="0" cy="0"/>
+          <a:chOff x="0" y="0"/>
+          <a:chExt cx="0" cy="0"/>
+        </a:xfrm>
+      </p:grpSpPr>
+      <p:sp>
+        <p:nvSpPr>
+          <p:cNvPr id="2" name="Slide Image Placeholder 1"/>
+          <p:cNvSpPr>
+            <a:spLocks noGrp="1"/>
+          </p:cNvSpPr>
+          <p:nvPr>
+            <p:ph type="sldImg" idx="2"/>
+          </p:nvPr>
+        </p:nvSpPr>
+        <p:spPr/>
+      </p:sp>
+      <p:sp>
+        <p:nvSpPr>
+          <p:cNvPr id="3" name="Notes Placeholder 2"/>
+          <p:cNvSpPr>
+            <a:spLocks noGrp="1"/>
+          </p:cNvSpPr>
+          <p:nvPr>
+            <p:ph type="body" idx="3" sz="quarter"/>
+          </p:nvPr>
+        </p:nvSpPr>
+        <p:spPr/>
+        <p:txBody>
+          <a:bodyPr/>
+          <a:lstStyle/>
+          <a:p>
+            <a:r>
+              <a:t>Mentor review summary: 09. Conceptual Data Model — Detail 4/4. Use this diagram to explain the actors/components, the direction of the flow, the CAP/backend control boundary, and the observable data or side effect. Canonical source asset: 09-conceptual-data-model.png; editable source and manifest are kept in docs/diagrams/rendered.</a:t>
+            </a:r>
+          </a:p>
+        </p:txBody>
+      </p:sp>
+      <p:sp>
+        <p:nvSpPr>
+          <p:cNvPr id="4" name="Slide Number Placeholder 3"/>
+          <p:cNvSpPr>
+            <a:spLocks noGrp="1"/>
+          </p:cNvSpPr>
+          <p:nvPr>
+            <p:ph type="sldNum" idx="5" sz="quarter"/>
+          </p:nvPr>
+        </p:nvSpPr>
+        <p:spPr/>
+      </p:sp>
+    </p:spTree>
+  </p:cSld>
+  <p:clrMapOvr>
+    <a:masterClrMapping/>
+  </p:clrMapOvr>
+</p:notes>
+</file>
+
+<file path=ppt/notesSlides/notesSlide25.xml><?xml version="1.0" encoding="utf-8"?>
+<p:notes xmlns:a="http://schemas.openxmlformats.org/drawingml/2006/main" xmlns:p="http://schemas.openxmlformats.org/presentationml/2006/main" xmlns:r="http://schemas.openxmlformats.org/officeDocument/2006/relationships">
+  <p:cSld>
+    <p:spTree>
+      <p:nvGrpSpPr>
+        <p:cNvPr id="1" name=""/>
+        <p:cNvGrpSpPr/>
+        <p:nvPr/>
+      </p:nvGrpSpPr>
+      <p:grpSpPr>
+        <a:xfrm>
+          <a:off x="0" y="0"/>
+          <a:ext cx="0" cy="0"/>
+          <a:chOff x="0" y="0"/>
+          <a:chExt cx="0" cy="0"/>
+        </a:xfrm>
+      </p:grpSpPr>
+      <p:sp>
+        <p:nvSpPr>
+          <p:cNvPr id="2" name="Slide Image Placeholder 1"/>
+          <p:cNvSpPr>
+            <a:spLocks noGrp="1"/>
+          </p:cNvSpPr>
+          <p:nvPr>
+            <p:ph type="sldImg" idx="2"/>
+          </p:nvPr>
+        </p:nvSpPr>
+        <p:spPr/>
+      </p:sp>
+      <p:sp>
+        <p:nvSpPr>
+          <p:cNvPr id="3" name="Notes Placeholder 2"/>
+          <p:cNvSpPr>
+            <a:spLocks noGrp="1"/>
+          </p:cNvSpPr>
+          <p:nvPr>
+            <p:ph type="body" idx="3" sz="quarter"/>
+          </p:nvPr>
+        </p:nvSpPr>
+        <p:spPr/>
+        <p:txBody>
+          <a:bodyPr/>
+          <a:lstStyle/>
+          <a:p>
+            <a:r>
+              <a:t>Mentor review summary: 10. Submit Bug and Notification Sequence — Overview. Use this diagram to explain the actors/components, the direction of the flow, the CAP/backend control boundary, and the observable data or side effect. Canonical source asset: 10-submit-notification.png; editable source and manifest are kept in docs/diagrams/rendered.</a:t>
+            </a:r>
+          </a:p>
+        </p:txBody>
+      </p:sp>
+      <p:sp>
+        <p:nvSpPr>
+          <p:cNvPr id="4" name="Slide Number Placeholder 3"/>
+          <p:cNvSpPr>
+            <a:spLocks noGrp="1"/>
+          </p:cNvSpPr>
+          <p:nvPr>
+            <p:ph type="sldNum" idx="5" sz="quarter"/>
+          </p:nvPr>
+        </p:nvSpPr>
+        <p:spPr/>
+      </p:sp>
+    </p:spTree>
+  </p:cSld>
+  <p:clrMapOvr>
+    <a:masterClrMapping/>
+  </p:clrMapOvr>
+</p:notes>
+</file>
+
+<file path=ppt/notesSlides/notesSlide26.xml><?xml version="1.0" encoding="utf-8"?>
+<p:notes xmlns:a="http://schemas.openxmlformats.org/drawingml/2006/main" xmlns:p="http://schemas.openxmlformats.org/presentationml/2006/main" xmlns:r="http://schemas.openxmlformats.org/officeDocument/2006/relationships">
+  <p:cSld>
+    <p:spTree>
+      <p:nvGrpSpPr>
+        <p:cNvPr id="1" name=""/>
+        <p:cNvGrpSpPr/>
+        <p:nvPr/>
+      </p:nvGrpSpPr>
+      <p:grpSpPr>
+        <a:xfrm>
+          <a:off x="0" y="0"/>
+          <a:ext cx="0" cy="0"/>
+          <a:chOff x="0" y="0"/>
+          <a:chExt cx="0" cy="0"/>
+        </a:xfrm>
+      </p:grpSpPr>
+      <p:sp>
+        <p:nvSpPr>
+          <p:cNvPr id="2" name="Slide Image Placeholder 1"/>
+          <p:cNvSpPr>
+            <a:spLocks noGrp="1"/>
+          </p:cNvSpPr>
+          <p:nvPr>
+            <p:ph type="sldImg" idx="2"/>
+          </p:nvPr>
+        </p:nvSpPr>
+        <p:spPr/>
+      </p:sp>
+      <p:sp>
+        <p:nvSpPr>
+          <p:cNvPr id="3" name="Notes Placeholder 2"/>
+          <p:cNvSpPr>
+            <a:spLocks noGrp="1"/>
+          </p:cNvSpPr>
+          <p:nvPr>
+            <p:ph type="body" idx="3" sz="quarter"/>
+          </p:nvPr>
+        </p:nvSpPr>
+        <p:spPr/>
+        <p:txBody>
+          <a:bodyPr/>
+          <a:lstStyle/>
+          <a:p>
+            <a:r>
+              <a:t>Mentor review summary: 10. Submit Bug and Notification Sequence — Detail 1/2. Use this diagram to explain the actors/components, the direction of the flow, the CAP/backend control boundary, and the observable data or side effect. Canonical source asset: 10-submit-notification.png; editable source and manifest are kept in docs/diagrams/rendered.</a:t>
+            </a:r>
+          </a:p>
+        </p:txBody>
+      </p:sp>
+      <p:sp>
+        <p:nvSpPr>
+          <p:cNvPr id="4" name="Slide Number Placeholder 3"/>
+          <p:cNvSpPr>
+            <a:spLocks noGrp="1"/>
+          </p:cNvSpPr>
+          <p:nvPr>
+            <p:ph type="sldNum" idx="5" sz="quarter"/>
+          </p:nvPr>
+        </p:nvSpPr>
+        <p:spPr/>
+      </p:sp>
+    </p:spTree>
+  </p:cSld>
+  <p:clrMapOvr>
+    <a:masterClrMapping/>
+  </p:clrMapOvr>
+</p:notes>
+</file>
+
+<file path=ppt/notesSlides/notesSlide27.xml><?xml version="1.0" encoding="utf-8"?>
+<p:notes xmlns:a="http://schemas.openxmlformats.org/drawingml/2006/main" xmlns:p="http://schemas.openxmlformats.org/presentationml/2006/main" xmlns:r="http://schemas.openxmlformats.org/officeDocument/2006/relationships">
+  <p:cSld>
+    <p:spTree>
+      <p:nvGrpSpPr>
+        <p:cNvPr id="1" name=""/>
+        <p:cNvGrpSpPr/>
+        <p:nvPr/>
+      </p:nvGrpSpPr>
+      <p:grpSpPr>
+        <a:xfrm>
+          <a:off x="0" y="0"/>
+          <a:ext cx="0" cy="0"/>
+          <a:chOff x="0" y="0"/>
+          <a:chExt cx="0" cy="0"/>
+        </a:xfrm>
+      </p:grpSpPr>
+      <p:sp>
+        <p:nvSpPr>
+          <p:cNvPr id="2" name="Slide Image Placeholder 1"/>
+          <p:cNvSpPr>
+            <a:spLocks noGrp="1"/>
+          </p:cNvSpPr>
+          <p:nvPr>
+            <p:ph type="sldImg" idx="2"/>
+          </p:nvPr>
+        </p:nvSpPr>
+        <p:spPr/>
+      </p:sp>
+      <p:sp>
+        <p:nvSpPr>
+          <p:cNvPr id="3" name="Notes Placeholder 2"/>
+          <p:cNvSpPr>
+            <a:spLocks noGrp="1"/>
+          </p:cNvSpPr>
+          <p:nvPr>
+            <p:ph type="body" idx="3" sz="quarter"/>
+          </p:nvPr>
+        </p:nvSpPr>
+        <p:spPr/>
+        <p:txBody>
+          <a:bodyPr/>
+          <a:lstStyle/>
+          <a:p>
+            <a:r>
+              <a:t>Mentor review summary: 10. Submit Bug and Notification Sequence — Detail 2/2. Use this diagram to explain the actors/components, the direction of the flow, the CAP/backend control boundary, and the observable data or side effect. Canonical source asset: 10-submit-notification.png; editable source and manifest are kept in docs/diagrams/rendered.</a:t>
+            </a:r>
+          </a:p>
+        </p:txBody>
+      </p:sp>
+      <p:sp>
+        <p:nvSpPr>
+          <p:cNvPr id="4" name="Slide Number Placeholder 3"/>
+          <p:cNvSpPr>
+            <a:spLocks noGrp="1"/>
+          </p:cNvSpPr>
+          <p:nvPr>
+            <p:ph type="sldNum" idx="5" sz="quarter"/>
+          </p:nvPr>
+        </p:nvSpPr>
+        <p:spPr/>
+      </p:sp>
+    </p:spTree>
+  </p:cSld>
+  <p:clrMapOvr>
+    <a:masterClrMapping/>
+  </p:clrMapOvr>
+</p:notes>
+</file>
+
+<file path=ppt/notesSlides/notesSlide28.xml><?xml version="1.0" encoding="utf-8"?>
+<p:notes xmlns:a="http://schemas.openxmlformats.org/drawingml/2006/main" xmlns:p="http://schemas.openxmlformats.org/presentationml/2006/main" xmlns:r="http://schemas.openxmlformats.org/officeDocument/2006/relationships">
+  <p:cSld>
+    <p:spTree>
+      <p:nvGrpSpPr>
+        <p:cNvPr id="1" name=""/>
+        <p:cNvGrpSpPr/>
+        <p:nvPr/>
+      </p:nvGrpSpPr>
+      <p:grpSpPr>
+        <a:xfrm>
+          <a:off x="0" y="0"/>
+          <a:ext cx="0" cy="0"/>
+          <a:chOff x="0" y="0"/>
+          <a:chExt cx="0" cy="0"/>
+        </a:xfrm>
+      </p:grpSpPr>
+      <p:sp>
+        <p:nvSpPr>
+          <p:cNvPr id="2" name="Slide Image Placeholder 1"/>
+          <p:cNvSpPr>
+            <a:spLocks noGrp="1"/>
+          </p:cNvSpPr>
+          <p:nvPr>
+            <p:ph type="sldImg" idx="2"/>
+          </p:nvPr>
+        </p:nvSpPr>
+        <p:spPr/>
+      </p:sp>
+      <p:sp>
+        <p:nvSpPr>
+          <p:cNvPr id="3" name="Notes Placeholder 2"/>
+          <p:cNvSpPr>
+            <a:spLocks noGrp="1"/>
+          </p:cNvSpPr>
+          <p:nvPr>
+            <p:ph type="body" idx="3" sz="quarter"/>
+          </p:nvPr>
+        </p:nvSpPr>
+        <p:spPr/>
+        <p:txBody>
+          <a:bodyPr/>
+          <a:lstStyle/>
+          <a:p>
+            <a:r>
+              <a:t>Mentor review summary: 11. Developer Review Notification Sequence — Overview. Use this diagram to explain the actors/components, the direction of the flow, the CAP/backend control boundary, and the observable data or side effect. Canonical source asset: 11-developer-review-notification.png; editable source and manifest are kept in docs/diagrams/rendered.</a:t>
+            </a:r>
+          </a:p>
+        </p:txBody>
+      </p:sp>
+      <p:sp>
+        <p:nvSpPr>
+          <p:cNvPr id="4" name="Slide Number Placeholder 3"/>
+          <p:cNvSpPr>
+            <a:spLocks noGrp="1"/>
+          </p:cNvSpPr>
+          <p:nvPr>
+            <p:ph type="sldNum" idx="5" sz="quarter"/>
+          </p:nvPr>
+        </p:nvSpPr>
+        <p:spPr/>
+      </p:sp>
+    </p:spTree>
+  </p:cSld>
+  <p:clrMapOvr>
+    <a:masterClrMapping/>
+  </p:clrMapOvr>
+</p:notes>
+</file>
+
+<file path=ppt/notesSlides/notesSlide29.xml><?xml version="1.0" encoding="utf-8"?>
+<p:notes xmlns:a="http://schemas.openxmlformats.org/drawingml/2006/main" xmlns:p="http://schemas.openxmlformats.org/presentationml/2006/main" xmlns:r="http://schemas.openxmlformats.org/officeDocument/2006/relationships">
+  <p:cSld>
+    <p:spTree>
+      <p:nvGrpSpPr>
+        <p:cNvPr id="1" name=""/>
+        <p:cNvGrpSpPr/>
+        <p:nvPr/>
+      </p:nvGrpSpPr>
+      <p:grpSpPr>
+        <a:xfrm>
+          <a:off x="0" y="0"/>
+          <a:ext cx="0" cy="0"/>
+          <a:chOff x="0" y="0"/>
+          <a:chExt cx="0" cy="0"/>
+        </a:xfrm>
+      </p:grpSpPr>
+      <p:sp>
+        <p:nvSpPr>
+          <p:cNvPr id="2" name="Slide Image Placeholder 1"/>
+          <p:cNvSpPr>
+            <a:spLocks noGrp="1"/>
+          </p:cNvSpPr>
+          <p:nvPr>
+            <p:ph type="sldImg" idx="2"/>
+          </p:nvPr>
+        </p:nvSpPr>
+        <p:spPr/>
+      </p:sp>
+      <p:sp>
+        <p:nvSpPr>
+          <p:cNvPr id="3" name="Notes Placeholder 2"/>
+          <p:cNvSpPr>
+            <a:spLocks noGrp="1"/>
+          </p:cNvSpPr>
+          <p:nvPr>
+            <p:ph type="body" idx="3" sz="quarter"/>
+          </p:nvPr>
+        </p:nvSpPr>
+        <p:spPr/>
+        <p:txBody>
+          <a:bodyPr/>
+          <a:lstStyle/>
+          <a:p>
+            <a:r>
+              <a:t>Mentor review summary: 11. Developer Review Notification Sequence — Detail 1/2. Use this diagram to explain the actors/components, the direction of the flow, the CAP/backend control boundary, and the observable data or side effect. Canonical source asset: 11-developer-review-notification.png; editable source and manifest are kept in docs/diagrams/rendered.</a:t>
+            </a:r>
+          </a:p>
+        </p:txBody>
+      </p:sp>
+      <p:sp>
+        <p:nvSpPr>
+          <p:cNvPr id="4" name="Slide Number Placeholder 3"/>
+          <p:cNvSpPr>
+            <a:spLocks noGrp="1"/>
+          </p:cNvSpPr>
+          <p:nvPr>
+            <p:ph type="sldNum" idx="5" sz="quarter"/>
+          </p:nvPr>
+        </p:nvSpPr>
+        <p:spPr/>
+      </p:sp>
+    </p:spTree>
+  </p:cSld>
+  <p:clrMapOvr>
+    <a:masterClrMapping/>
+  </p:clrMapOvr>
+</p:notes>
+</file>
+
+<file path=ppt/notesSlides/notesSlide3.xml><?xml version="1.0" encoding="utf-8"?>
+<p:notes xmlns:a="http://schemas.openxmlformats.org/drawingml/2006/main" xmlns:p="http://schemas.openxmlformats.org/presentationml/2006/main" xmlns:r="http://schemas.openxmlformats.org/officeDocument/2006/relationships">
+  <p:cSld>
+    <p:spTree>
+      <p:nvGrpSpPr>
+        <p:cNvPr id="1" name=""/>
+        <p:cNvGrpSpPr/>
+        <p:nvPr/>
+      </p:nvGrpSpPr>
+      <p:grpSpPr>
+        <a:xfrm>
+          <a:off x="0" y="0"/>
+          <a:ext cx="0" cy="0"/>
+          <a:chOff x="0" y="0"/>
+          <a:chExt cx="0" cy="0"/>
+        </a:xfrm>
+      </p:grpSpPr>
+      <p:sp>
+        <p:nvSpPr>
+          <p:cNvPr id="2" name="Slide Image Placeholder 1"/>
+          <p:cNvSpPr>
+            <a:spLocks noGrp="1"/>
+          </p:cNvSpPr>
+          <p:nvPr>
+            <p:ph type="sldImg" idx="2"/>
+          </p:nvPr>
+        </p:nvSpPr>
+        <p:spPr/>
+      </p:sp>
+      <p:sp>
+        <p:nvSpPr>
+          <p:cNvPr id="3" name="Notes Placeholder 2"/>
+          <p:cNvSpPr>
+            <a:spLocks noGrp="1"/>
+          </p:cNvSpPr>
+          <p:nvPr>
+            <p:ph type="body" idx="3" sz="quarter"/>
+          </p:nvPr>
+        </p:nvSpPr>
+        <p:spPr/>
+        <p:txBody>
+          <a:bodyPr/>
+          <a:lstStyle/>
+          <a:p>
+            <a:r>
+              <a:t>Mentor review summary: 03. Use Case Diagram — Overview. Use this diagram to explain the actors/components, the direction of the flow, the CAP/backend control boundary, and the observable data or side effect. Canonical source asset: 03-use-case.png; editable source and manifest are kept in docs/diagrams/rendered.</a:t>
+            </a:r>
+          </a:p>
+        </p:txBody>
+      </p:sp>
+      <p:sp>
+        <p:nvSpPr>
+          <p:cNvPr id="4" name="Slide Number Placeholder 3"/>
+          <p:cNvSpPr>
+            <a:spLocks noGrp="1"/>
+          </p:cNvSpPr>
+          <p:nvPr>
+            <p:ph type="sldNum" idx="5" sz="quarter"/>
+          </p:nvPr>
+        </p:nvSpPr>
+        <p:spPr/>
+      </p:sp>
+    </p:spTree>
+  </p:cSld>
+  <p:clrMapOvr>
+    <a:masterClrMapping/>
+  </p:clrMapOvr>
+</p:notes>
+</file>
+
+<file path=ppt/notesSlides/notesSlide30.xml><?xml version="1.0" encoding="utf-8"?>
+<p:notes xmlns:a="http://schemas.openxmlformats.org/drawingml/2006/main" xmlns:p="http://schemas.openxmlformats.org/presentationml/2006/main" xmlns:r="http://schemas.openxmlformats.org/officeDocument/2006/relationships">
+  <p:cSld>
+    <p:spTree>
+      <p:nvGrpSpPr>
+        <p:cNvPr id="1" name=""/>
+        <p:cNvGrpSpPr/>
+        <p:nvPr/>
+      </p:nvGrpSpPr>
+      <p:grpSpPr>
+        <a:xfrm>
+          <a:off x="0" y="0"/>
+          <a:ext cx="0" cy="0"/>
+          <a:chOff x="0" y="0"/>
+          <a:chExt cx="0" cy="0"/>
+        </a:xfrm>
+      </p:grpSpPr>
+      <p:sp>
+        <p:nvSpPr>
+          <p:cNvPr id="2" name="Slide Image Placeholder 1"/>
+          <p:cNvSpPr>
+            <a:spLocks noGrp="1"/>
+          </p:cNvSpPr>
+          <p:nvPr>
+            <p:ph type="sldImg" idx="2"/>
+          </p:nvPr>
+        </p:nvSpPr>
+        <p:spPr/>
+      </p:sp>
+      <p:sp>
+        <p:nvSpPr>
+          <p:cNvPr id="3" name="Notes Placeholder 2"/>
+          <p:cNvSpPr>
+            <a:spLocks noGrp="1"/>
+          </p:cNvSpPr>
+          <p:nvPr>
+            <p:ph type="body" idx="3" sz="quarter"/>
+          </p:nvPr>
+        </p:nvSpPr>
+        <p:spPr/>
+        <p:txBody>
+          <a:bodyPr/>
+          <a:lstStyle/>
+          <a:p>
+            <a:r>
+              <a:t>Mentor review summary: 11. Developer Review Notification Sequence — Detail 2/2. Use this diagram to explain the actors/components, the direction of the flow, the CAP/backend control boundary, and the observable data or side effect. Canonical source asset: 11-developer-review-notification.png; editable source and manifest are kept in docs/diagrams/rendered.</a:t>
+            </a:r>
+          </a:p>
+        </p:txBody>
+      </p:sp>
+      <p:sp>
+        <p:nvSpPr>
+          <p:cNvPr id="4" name="Slide Number Placeholder 3"/>
+          <p:cNvSpPr>
+            <a:spLocks noGrp="1"/>
+          </p:cNvSpPr>
+          <p:nvPr>
+            <p:ph type="sldNum" idx="5" sz="quarter"/>
+          </p:nvPr>
+        </p:nvSpPr>
+        <p:spPr/>
+      </p:sp>
+    </p:spTree>
+  </p:cSld>
+  <p:clrMapOvr>
+    <a:masterClrMapping/>
+  </p:clrMapOvr>
+</p:notes>
+</file>
+
+<file path=ppt/notesSlides/notesSlide31.xml><?xml version="1.0" encoding="utf-8"?>
+<p:notes xmlns:a="http://schemas.openxmlformats.org/drawingml/2006/main" xmlns:p="http://schemas.openxmlformats.org/presentationml/2006/main" xmlns:r="http://schemas.openxmlformats.org/officeDocument/2006/relationships">
+  <p:cSld>
+    <p:spTree>
+      <p:nvGrpSpPr>
+        <p:cNvPr id="1" name=""/>
+        <p:cNvGrpSpPr/>
+        <p:nvPr/>
+      </p:nvGrpSpPr>
+      <p:grpSpPr>
+        <a:xfrm>
+          <a:off x="0" y="0"/>
+          <a:ext cx="0" cy="0"/>
+          <a:chOff x="0" y="0"/>
+          <a:chExt cx="0" cy="0"/>
+        </a:xfrm>
+      </p:grpSpPr>
+      <p:sp>
+        <p:nvSpPr>
+          <p:cNvPr id="2" name="Slide Image Placeholder 1"/>
+          <p:cNvSpPr>
+            <a:spLocks noGrp="1"/>
+          </p:cNvSpPr>
+          <p:nvPr>
+            <p:ph type="sldImg" idx="2"/>
+          </p:nvPr>
+        </p:nvSpPr>
+        <p:spPr/>
+      </p:sp>
+      <p:sp>
+        <p:nvSpPr>
+          <p:cNvPr id="3" name="Notes Placeholder 2"/>
+          <p:cNvSpPr>
+            <a:spLocks noGrp="1"/>
+          </p:cNvSpPr>
+          <p:nvPr>
+            <p:ph type="body" idx="3" sz="quarter"/>
+          </p:nvPr>
+        </p:nvSpPr>
+        <p:spPr/>
+        <p:txBody>
+          <a:bodyPr/>
+          <a:lstStyle/>
+          <a:p>
+            <a:r>
+              <a:t>Mentor review summary: 12. PM Monitoring and Escalation Flow — Overview. Use this diagram to explain the actors/components, the direction of the flow, the CAP/backend control boundary, and the observable data or side effect. Canonical source asset: 12-pm-monitoring.png; editable source and manifest are kept in docs/diagrams/rendered.</a:t>
+            </a:r>
+          </a:p>
+        </p:txBody>
+      </p:sp>
+      <p:sp>
+        <p:nvSpPr>
+          <p:cNvPr id="4" name="Slide Number Placeholder 3"/>
+          <p:cNvSpPr>
+            <a:spLocks noGrp="1"/>
+          </p:cNvSpPr>
+          <p:nvPr>
+            <p:ph type="sldNum" idx="5" sz="quarter"/>
+          </p:nvPr>
+        </p:nvSpPr>
+        <p:spPr/>
+      </p:sp>
+    </p:spTree>
+  </p:cSld>
+  <p:clrMapOvr>
+    <a:masterClrMapping/>
+  </p:clrMapOvr>
+</p:notes>
+</file>
+
+<file path=ppt/notesSlides/notesSlide32.xml><?xml version="1.0" encoding="utf-8"?>
+<p:notes xmlns:a="http://schemas.openxmlformats.org/drawingml/2006/main" xmlns:p="http://schemas.openxmlformats.org/presentationml/2006/main" xmlns:r="http://schemas.openxmlformats.org/officeDocument/2006/relationships">
+  <p:cSld>
+    <p:spTree>
+      <p:nvGrpSpPr>
+        <p:cNvPr id="1" name=""/>
+        <p:cNvGrpSpPr/>
+        <p:nvPr/>
+      </p:nvGrpSpPr>
+      <p:grpSpPr>
+        <a:xfrm>
+          <a:off x="0" y="0"/>
+          <a:ext cx="0" cy="0"/>
+          <a:chOff x="0" y="0"/>
+          <a:chExt cx="0" cy="0"/>
+        </a:xfrm>
+      </p:grpSpPr>
+      <p:sp>
+        <p:nvSpPr>
+          <p:cNvPr id="2" name="Slide Image Placeholder 1"/>
+          <p:cNvSpPr>
+            <a:spLocks noGrp="1"/>
+          </p:cNvSpPr>
+          <p:nvPr>
+            <p:ph type="sldImg" idx="2"/>
+          </p:nvPr>
+        </p:nvSpPr>
+        <p:spPr/>
+      </p:sp>
+      <p:sp>
+        <p:nvSpPr>
+          <p:cNvPr id="3" name="Notes Placeholder 2"/>
+          <p:cNvSpPr>
+            <a:spLocks noGrp="1"/>
+          </p:cNvSpPr>
+          <p:nvPr>
+            <p:ph type="body" idx="3" sz="quarter"/>
+          </p:nvPr>
+        </p:nvSpPr>
+        <p:spPr/>
+        <p:txBody>
+          <a:bodyPr/>
+          <a:lstStyle/>
+          <a:p>
+            <a:r>
+              <a:t>Mentor review summary: 13. SRS System Context — Overview. Use this diagram to explain the actors/components, the direction of the flow, the CAP/backend control boundary, and the observable data or side effect. Canonical source asset: 13-srs-system-context.png; editable source and manifest are kept in docs/diagrams/rendered.</a:t>
+            </a:r>
+          </a:p>
+        </p:txBody>
+      </p:sp>
+      <p:sp>
+        <p:nvSpPr>
+          <p:cNvPr id="4" name="Slide Number Placeholder 3"/>
+          <p:cNvSpPr>
+            <a:spLocks noGrp="1"/>
+          </p:cNvSpPr>
+          <p:nvPr>
+            <p:ph type="sldNum" idx="5" sz="quarter"/>
+          </p:nvPr>
+        </p:nvSpPr>
+        <p:spPr/>
+      </p:sp>
+    </p:spTree>
+  </p:cSld>
+  <p:clrMapOvr>
+    <a:masterClrMapping/>
+  </p:clrMapOvr>
+</p:notes>
+</file>
+
+<file path=ppt/notesSlides/notesSlide33.xml><?xml version="1.0" encoding="utf-8"?>
+<p:notes xmlns:a="http://schemas.openxmlformats.org/drawingml/2006/main" xmlns:p="http://schemas.openxmlformats.org/presentationml/2006/main" xmlns:r="http://schemas.openxmlformats.org/officeDocument/2006/relationships">
+  <p:cSld>
+    <p:spTree>
+      <p:nvGrpSpPr>
+        <p:cNvPr id="1" name=""/>
+        <p:cNvGrpSpPr/>
+        <p:nvPr/>
+      </p:nvGrpSpPr>
+      <p:grpSpPr>
+        <a:xfrm>
+          <a:off x="0" y="0"/>
+          <a:ext cx="0" cy="0"/>
+          <a:chOff x="0" y="0"/>
+          <a:chExt cx="0" cy="0"/>
+        </a:xfrm>
+      </p:grpSpPr>
+      <p:sp>
+        <p:nvSpPr>
+          <p:cNvPr id="2" name="Slide Image Placeholder 1"/>
+          <p:cNvSpPr>
+            <a:spLocks noGrp="1"/>
+          </p:cNvSpPr>
+          <p:nvPr>
+            <p:ph type="sldImg" idx="2"/>
+          </p:nvPr>
+        </p:nvSpPr>
+        <p:spPr/>
+      </p:sp>
+      <p:sp>
+        <p:nvSpPr>
+          <p:cNvPr id="3" name="Notes Placeholder 2"/>
+          <p:cNvSpPr>
+            <a:spLocks noGrp="1"/>
+          </p:cNvSpPr>
+          <p:nvPr>
+            <p:ph type="body" idx="3" sz="quarter"/>
+          </p:nvPr>
+        </p:nvSpPr>
+        <p:spPr/>
+        <p:txBody>
+          <a:bodyPr/>
+          <a:lstStyle/>
+          <a:p>
+            <a:r>
+              <a:t>Mentor review summary: 14. Main Defect Tracking Flow — Overview. Use this diagram to explain the actors/components, the direction of the flow, the CAP/backend control boundary, and the observable data or side effect. Canonical source asset: 14-frs-main-defect-flow.png; editable source and manifest are kept in docs/diagrams/rendered.</a:t>
+            </a:r>
+          </a:p>
+        </p:txBody>
+      </p:sp>
+      <p:sp>
+        <p:nvSpPr>
+          <p:cNvPr id="4" name="Slide Number Placeholder 3"/>
+          <p:cNvSpPr>
+            <a:spLocks noGrp="1"/>
+          </p:cNvSpPr>
+          <p:nvPr>
+            <p:ph type="sldNum" idx="5" sz="quarter"/>
+          </p:nvPr>
+        </p:nvSpPr>
+        <p:spPr/>
+      </p:sp>
+    </p:spTree>
+  </p:cSld>
+  <p:clrMapOvr>
+    <a:masterClrMapping/>
+  </p:clrMapOvr>
+</p:notes>
+</file>
+
+<file path=ppt/notesSlides/notesSlide34.xml><?xml version="1.0" encoding="utf-8"?>
+<p:notes xmlns:a="http://schemas.openxmlformats.org/drawingml/2006/main" xmlns:p="http://schemas.openxmlformats.org/presentationml/2006/main" xmlns:r="http://schemas.openxmlformats.org/officeDocument/2006/relationships">
+  <p:cSld>
+    <p:spTree>
+      <p:nvGrpSpPr>
+        <p:cNvPr id="1" name=""/>
+        <p:cNvGrpSpPr/>
+        <p:nvPr/>
+      </p:nvGrpSpPr>
+      <p:grpSpPr>
+        <a:xfrm>
+          <a:off x="0" y="0"/>
+          <a:ext cx="0" cy="0"/>
+          <a:chOff x="0" y="0"/>
+          <a:chExt cx="0" cy="0"/>
+        </a:xfrm>
+      </p:grpSpPr>
+      <p:sp>
+        <p:nvSpPr>
+          <p:cNvPr id="2" name="Slide Image Placeholder 1"/>
+          <p:cNvSpPr>
+            <a:spLocks noGrp="1"/>
+          </p:cNvSpPr>
+          <p:nvPr>
+            <p:ph type="sldImg" idx="2"/>
+          </p:nvPr>
+        </p:nvSpPr>
+        <p:spPr/>
+      </p:sp>
+      <p:sp>
+        <p:nvSpPr>
+          <p:cNvPr id="3" name="Notes Placeholder 2"/>
+          <p:cNvSpPr>
+            <a:spLocks noGrp="1"/>
+          </p:cNvSpPr>
+          <p:nvPr>
+            <p:ph type="body" idx="3" sz="quarter"/>
+          </p:nvPr>
+        </p:nvSpPr>
+        <p:spPr/>
+        <p:txBody>
+          <a:bodyPr/>
+          <a:lstStyle/>
+          <a:p>
+            <a:r>
+              <a:t>Mentor review summary: 14. Main Defect Tracking Flow — Detail 1/2. Use this diagram to explain the actors/components, the direction of the flow, the CAP/backend control boundary, and the observable data or side effect. Canonical source asset: 14-frs-main-defect-flow.png; editable source and manifest are kept in docs/diagrams/rendered.</a:t>
+            </a:r>
+          </a:p>
+        </p:txBody>
+      </p:sp>
+      <p:sp>
+        <p:nvSpPr>
+          <p:cNvPr id="4" name="Slide Number Placeholder 3"/>
+          <p:cNvSpPr>
+            <a:spLocks noGrp="1"/>
+          </p:cNvSpPr>
+          <p:nvPr>
+            <p:ph type="sldNum" idx="5" sz="quarter"/>
+          </p:nvPr>
+        </p:nvSpPr>
+        <p:spPr/>
+      </p:sp>
+    </p:spTree>
+  </p:cSld>
+  <p:clrMapOvr>
+    <a:masterClrMapping/>
+  </p:clrMapOvr>
+</p:notes>
+</file>
+
+<file path=ppt/notesSlides/notesSlide35.xml><?xml version="1.0" encoding="utf-8"?>
+<p:notes xmlns:a="http://schemas.openxmlformats.org/drawingml/2006/main" xmlns:p="http://schemas.openxmlformats.org/presentationml/2006/main" xmlns:r="http://schemas.openxmlformats.org/officeDocument/2006/relationships">
+  <p:cSld>
+    <p:spTree>
+      <p:nvGrpSpPr>
+        <p:cNvPr id="1" name=""/>
+        <p:cNvGrpSpPr/>
+        <p:nvPr/>
+      </p:nvGrpSpPr>
+      <p:grpSpPr>
+        <a:xfrm>
+          <a:off x="0" y="0"/>
+          <a:ext cx="0" cy="0"/>
+          <a:chOff x="0" y="0"/>
+          <a:chExt cx="0" cy="0"/>
+        </a:xfrm>
+      </p:grpSpPr>
+      <p:sp>
+        <p:nvSpPr>
+          <p:cNvPr id="2" name="Slide Image Placeholder 1"/>
+          <p:cNvSpPr>
+            <a:spLocks noGrp="1"/>
+          </p:cNvSpPr>
+          <p:nvPr>
+            <p:ph type="sldImg" idx="2"/>
+          </p:nvPr>
+        </p:nvSpPr>
+        <p:spPr/>
+      </p:sp>
+      <p:sp>
+        <p:nvSpPr>
+          <p:cNvPr id="3" name="Notes Placeholder 2"/>
+          <p:cNvSpPr>
+            <a:spLocks noGrp="1"/>
+          </p:cNvSpPr>
+          <p:nvPr>
+            <p:ph type="body" idx="3" sz="quarter"/>
+          </p:nvPr>
+        </p:nvSpPr>
+        <p:spPr/>
+        <p:txBody>
+          <a:bodyPr/>
+          <a:lstStyle/>
+          <a:p>
+            <a:r>
+              <a:t>Mentor review summary: 14. Main Defect Tracking Flow — Detail 2/2. Use this diagram to explain the actors/components, the direction of the flow, the CAP/backend control boundary, and the observable data or side effect. Canonical source asset: 14-frs-main-defect-flow.png; editable source and manifest are kept in docs/diagrams/rendered.</a:t>
+            </a:r>
+          </a:p>
+        </p:txBody>
+      </p:sp>
+      <p:sp>
+        <p:nvSpPr>
+          <p:cNvPr id="4" name="Slide Number Placeholder 3"/>
+          <p:cNvSpPr>
+            <a:spLocks noGrp="1"/>
+          </p:cNvSpPr>
+          <p:nvPr>
+            <p:ph type="sldNum" idx="5" sz="quarter"/>
+          </p:nvPr>
+        </p:nvSpPr>
+        <p:spPr/>
+      </p:sp>
+    </p:spTree>
+  </p:cSld>
+  <p:clrMapOvr>
+    <a:masterClrMapping/>
+  </p:clrMapOvr>
+</p:notes>
+</file>
+
+<file path=ppt/notesSlides/notesSlide36.xml><?xml version="1.0" encoding="utf-8"?>
+<p:notes xmlns:a="http://schemas.openxmlformats.org/drawingml/2006/main" xmlns:p="http://schemas.openxmlformats.org/presentationml/2006/main" xmlns:r="http://schemas.openxmlformats.org/officeDocument/2006/relationships">
+  <p:cSld>
+    <p:spTree>
+      <p:nvGrpSpPr>
+        <p:cNvPr id="1" name=""/>
+        <p:cNvGrpSpPr/>
+        <p:nvPr/>
+      </p:nvGrpSpPr>
+      <p:grpSpPr>
+        <a:xfrm>
+          <a:off x="0" y="0"/>
+          <a:ext cx="0" cy="0"/>
+          <a:chOff x="0" y="0"/>
+          <a:chExt cx="0" cy="0"/>
+        </a:xfrm>
+      </p:grpSpPr>
+      <p:sp>
+        <p:nvSpPr>
+          <p:cNvPr id="2" name="Slide Image Placeholder 1"/>
+          <p:cNvSpPr>
+            <a:spLocks noGrp="1"/>
+          </p:cNvSpPr>
+          <p:nvPr>
+            <p:ph type="sldImg" idx="2"/>
+          </p:nvPr>
+        </p:nvSpPr>
+        <p:spPr/>
+      </p:sp>
+      <p:sp>
+        <p:nvSpPr>
+          <p:cNvPr id="3" name="Notes Placeholder 2"/>
+          <p:cNvSpPr>
+            <a:spLocks noGrp="1"/>
+          </p:cNvSpPr>
+          <p:nvPr>
+            <p:ph type="body" idx="3" sz="quarter"/>
+          </p:nvPr>
+        </p:nvSpPr>
+        <p:spPr/>
+        <p:txBody>
+          <a:bodyPr/>
+          <a:lstStyle/>
+          <a:p>
+            <a:r>
+              <a:t>Mentor review summary: 15. Rejected Follow-up Flow — Overview. Use this diagram to explain the actors/components, the direction of the flow, the CAP/backend control boundary, and the observable data or side effect. Canonical source asset: 15-frs-rejected-follow-up.png; editable source and manifest are kept in docs/diagrams/rendered.</a:t>
+            </a:r>
+          </a:p>
+        </p:txBody>
+      </p:sp>
+      <p:sp>
+        <p:nvSpPr>
+          <p:cNvPr id="4" name="Slide Number Placeholder 3"/>
+          <p:cNvSpPr>
+            <a:spLocks noGrp="1"/>
+          </p:cNvSpPr>
+          <p:nvPr>
+            <p:ph type="sldNum" idx="5" sz="quarter"/>
+          </p:nvPr>
+        </p:nvSpPr>
+        <p:spPr/>
+      </p:sp>
+    </p:spTree>
+  </p:cSld>
+  <p:clrMapOvr>
+    <a:masterClrMapping/>
+  </p:clrMapOvr>
+</p:notes>
+</file>
+
+<file path=ppt/notesSlides/notesSlide37.xml><?xml version="1.0" encoding="utf-8"?>
+<p:notes xmlns:a="http://schemas.openxmlformats.org/drawingml/2006/main" xmlns:p="http://schemas.openxmlformats.org/presentationml/2006/main" xmlns:r="http://schemas.openxmlformats.org/officeDocument/2006/relationships">
+  <p:cSld>
+    <p:spTree>
+      <p:nvGrpSpPr>
+        <p:cNvPr id="1" name=""/>
+        <p:cNvGrpSpPr/>
+        <p:nvPr/>
+      </p:nvGrpSpPr>
+      <p:grpSpPr>
+        <a:xfrm>
+          <a:off x="0" y="0"/>
+          <a:ext cx="0" cy="0"/>
+          <a:chOff x="0" y="0"/>
+          <a:chExt cx="0" cy="0"/>
+        </a:xfrm>
+      </p:grpSpPr>
+      <p:sp>
+        <p:nvSpPr>
+          <p:cNvPr id="2" name="Slide Image Placeholder 1"/>
+          <p:cNvSpPr>
+            <a:spLocks noGrp="1"/>
+          </p:cNvSpPr>
+          <p:nvPr>
+            <p:ph type="sldImg" idx="2"/>
+          </p:nvPr>
+        </p:nvSpPr>
+        <p:spPr/>
+      </p:sp>
+      <p:sp>
+        <p:nvSpPr>
+          <p:cNvPr id="3" name="Notes Placeholder 2"/>
+          <p:cNvSpPr>
+            <a:spLocks noGrp="1"/>
+          </p:cNvSpPr>
+          <p:nvPr>
+            <p:ph type="body" idx="3" sz="quarter"/>
+          </p:nvPr>
+        </p:nvSpPr>
+        <p:spPr/>
+        <p:txBody>
+          <a:bodyPr/>
+          <a:lstStyle/>
+          <a:p>
+            <a:r>
+              <a:t>Mentor review summary: 16. Status Lifecycle — Overview. Use this diagram to explain the actors/components, the direction of the flow, the CAP/backend control boundary, and the observable data or side effect. Canonical source asset: 16-frs-status-lifecycle.png; editable source and manifest are kept in docs/diagrams/rendered.</a:t>
+            </a:r>
+          </a:p>
+        </p:txBody>
+      </p:sp>
+      <p:sp>
+        <p:nvSpPr>
+          <p:cNvPr id="4" name="Slide Number Placeholder 3"/>
+          <p:cNvSpPr>
+            <a:spLocks noGrp="1"/>
+          </p:cNvSpPr>
+          <p:nvPr>
+            <p:ph type="sldNum" idx="5" sz="quarter"/>
+          </p:nvPr>
+        </p:nvSpPr>
+        <p:spPr/>
+      </p:sp>
+    </p:spTree>
+  </p:cSld>
+  <p:clrMapOvr>
+    <a:masterClrMapping/>
+  </p:clrMapOvr>
+</p:notes>
+</file>
+
+<file path=ppt/notesSlides/notesSlide38.xml><?xml version="1.0" encoding="utf-8"?>
+<p:notes xmlns:a="http://schemas.openxmlformats.org/drawingml/2006/main" xmlns:p="http://schemas.openxmlformats.org/presentationml/2006/main" xmlns:r="http://schemas.openxmlformats.org/officeDocument/2006/relationships">
+  <p:cSld>
+    <p:spTree>
+      <p:nvGrpSpPr>
+        <p:cNvPr id="1" name=""/>
+        <p:cNvGrpSpPr/>
+        <p:nvPr/>
+      </p:nvGrpSpPr>
+      <p:grpSpPr>
+        <a:xfrm>
+          <a:off x="0" y="0"/>
+          <a:ext cx="0" cy="0"/>
+          <a:chOff x="0" y="0"/>
+          <a:chExt cx="0" cy="0"/>
+        </a:xfrm>
+      </p:grpSpPr>
+      <p:sp>
+        <p:nvSpPr>
+          <p:cNvPr id="2" name="Slide Image Placeholder 1"/>
+          <p:cNvSpPr>
+            <a:spLocks noGrp="1"/>
+          </p:cNvSpPr>
+          <p:nvPr>
+            <p:ph type="sldImg" idx="2"/>
+          </p:nvPr>
+        </p:nvSpPr>
+        <p:spPr/>
+      </p:sp>
+      <p:sp>
+        <p:nvSpPr>
+          <p:cNvPr id="3" name="Notes Placeholder 2"/>
+          <p:cNvSpPr>
+            <a:spLocks noGrp="1"/>
+          </p:cNvSpPr>
+          <p:nvPr>
+            <p:ph type="body" idx="3" sz="quarter"/>
+          </p:nvPr>
+        </p:nvSpPr>
+        <p:spPr/>
+        <p:txBody>
+          <a:bodyPr/>
+          <a:lstStyle/>
+          <a:p>
+            <a:r>
+              <a:t>Mentor review summary: 17. Bug Creation and Assignment Activity Flow — Overview. Use this diagram to explain the actors/components, the direction of the flow, the CAP/backend control boundary, and the observable data or side effect. Canonical source asset: 17-frs-create-assignment.png; editable source and manifest are kept in docs/diagrams/rendered.</a:t>
+            </a:r>
+          </a:p>
+        </p:txBody>
+      </p:sp>
+      <p:sp>
+        <p:nvSpPr>
+          <p:cNvPr id="4" name="Slide Number Placeholder 3"/>
+          <p:cNvSpPr>
+            <a:spLocks noGrp="1"/>
+          </p:cNvSpPr>
+          <p:nvPr>
+            <p:ph type="sldNum" idx="5" sz="quarter"/>
+          </p:nvPr>
+        </p:nvSpPr>
+        <p:spPr/>
+      </p:sp>
+    </p:spTree>
+  </p:cSld>
+  <p:clrMapOvr>
+    <a:masterClrMapping/>
+  </p:clrMapOvr>
+</p:notes>
+</file>
+
+<file path=ppt/notesSlides/notesSlide39.xml><?xml version="1.0" encoding="utf-8"?>
+<p:notes xmlns:a="http://schemas.openxmlformats.org/drawingml/2006/main" xmlns:p="http://schemas.openxmlformats.org/presentationml/2006/main" xmlns:r="http://schemas.openxmlformats.org/officeDocument/2006/relationships">
+  <p:cSld>
+    <p:spTree>
+      <p:nvGrpSpPr>
+        <p:cNvPr id="1" name=""/>
+        <p:cNvGrpSpPr/>
+        <p:nvPr/>
+      </p:nvGrpSpPr>
+      <p:grpSpPr>
+        <a:xfrm>
+          <a:off x="0" y="0"/>
+          <a:ext cx="0" cy="0"/>
+          <a:chOff x="0" y="0"/>
+          <a:chExt cx="0" cy="0"/>
+        </a:xfrm>
+      </p:grpSpPr>
+      <p:sp>
+        <p:nvSpPr>
+          <p:cNvPr id="2" name="Slide Image Placeholder 1"/>
+          <p:cNvSpPr>
+            <a:spLocks noGrp="1"/>
+          </p:cNvSpPr>
+          <p:nvPr>
+            <p:ph type="sldImg" idx="2"/>
+          </p:nvPr>
+        </p:nvSpPr>
+        <p:spPr/>
+      </p:sp>
+      <p:sp>
+        <p:nvSpPr>
+          <p:cNvPr id="3" name="Notes Placeholder 2"/>
+          <p:cNvSpPr>
+            <a:spLocks noGrp="1"/>
+          </p:cNvSpPr>
+          <p:nvPr>
+            <p:ph type="body" idx="3" sz="quarter"/>
+          </p:nvPr>
+        </p:nvSpPr>
+        <p:spPr/>
+        <p:txBody>
+          <a:bodyPr/>
+          <a:lstStyle/>
+          <a:p>
+            <a:r>
+              <a:t>Mentor review summary: 17. Bug Creation and Assignment Activity Flow — Detail 1/2. Use this diagram to explain the actors/components, the direction of the flow, the CAP/backend control boundary, and the observable data or side effect. Canonical source asset: 17-frs-create-assignment.png; editable source and manifest are kept in docs/diagrams/rendered.</a:t>
+            </a:r>
+          </a:p>
+        </p:txBody>
+      </p:sp>
+      <p:sp>
+        <p:nvSpPr>
+          <p:cNvPr id="4" name="Slide Number Placeholder 3"/>
+          <p:cNvSpPr>
+            <a:spLocks noGrp="1"/>
+          </p:cNvSpPr>
+          <p:nvPr>
+            <p:ph type="sldNum" idx="5" sz="quarter"/>
+          </p:nvPr>
+        </p:nvSpPr>
+        <p:spPr/>
+      </p:sp>
+    </p:spTree>
+  </p:cSld>
+  <p:clrMapOvr>
+    <a:masterClrMapping/>
+  </p:clrMapOvr>
+</p:notes>
+</file>
+
+<file path=ppt/notesSlides/notesSlide4.xml><?xml version="1.0" encoding="utf-8"?>
+<p:notes xmlns:a="http://schemas.openxmlformats.org/drawingml/2006/main" xmlns:p="http://schemas.openxmlformats.org/presentationml/2006/main" xmlns:r="http://schemas.openxmlformats.org/officeDocument/2006/relationships">
+  <p:cSld>
+    <p:spTree>
+      <p:nvGrpSpPr>
+        <p:cNvPr id="1" name=""/>
+        <p:cNvGrpSpPr/>
+        <p:nvPr/>
+      </p:nvGrpSpPr>
+      <p:grpSpPr>
+        <a:xfrm>
+          <a:off x="0" y="0"/>
+          <a:ext cx="0" cy="0"/>
+          <a:chOff x="0" y="0"/>
+          <a:chExt cx="0" cy="0"/>
+        </a:xfrm>
+      </p:grpSpPr>
+      <p:sp>
+        <p:nvSpPr>
+          <p:cNvPr id="2" name="Slide Image Placeholder 1"/>
+          <p:cNvSpPr>
+            <a:spLocks noGrp="1"/>
+          </p:cNvSpPr>
+          <p:nvPr>
+            <p:ph type="sldImg" idx="2"/>
+          </p:nvPr>
+        </p:nvSpPr>
+        <p:spPr/>
+      </p:sp>
+      <p:sp>
+        <p:nvSpPr>
+          <p:cNvPr id="3" name="Notes Placeholder 2"/>
+          <p:cNvSpPr>
+            <a:spLocks noGrp="1"/>
+          </p:cNvSpPr>
+          <p:nvPr>
+            <p:ph type="body" idx="3" sz="quarter"/>
+          </p:nvPr>
+        </p:nvSpPr>
+        <p:spPr/>
+        <p:txBody>
+          <a:bodyPr/>
+          <a:lstStyle/>
+          <a:p>
+            <a:r>
+              <a:t>Mentor review summary: 03. Use Case Diagram — Detail 1/3. Use this diagram to explain the actors/components, the direction of the flow, the CAP/backend control boundary, and the observable data or side effect. Canonical source asset: 03-use-case.png; editable source and manifest are kept in docs/diagrams/rendered.</a:t>
+            </a:r>
+          </a:p>
+        </p:txBody>
+      </p:sp>
+      <p:sp>
+        <p:nvSpPr>
+          <p:cNvPr id="4" name="Slide Number Placeholder 3"/>
+          <p:cNvSpPr>
+            <a:spLocks noGrp="1"/>
+          </p:cNvSpPr>
+          <p:nvPr>
+            <p:ph type="sldNum" idx="5" sz="quarter"/>
+          </p:nvPr>
+        </p:nvSpPr>
+        <p:spPr/>
+      </p:sp>
+    </p:spTree>
+  </p:cSld>
+  <p:clrMapOvr>
+    <a:masterClrMapping/>
+  </p:clrMapOvr>
+</p:notes>
+</file>
+
+<file path=ppt/notesSlides/notesSlide40.xml><?xml version="1.0" encoding="utf-8"?>
+<p:notes xmlns:a="http://schemas.openxmlformats.org/drawingml/2006/main" xmlns:p="http://schemas.openxmlformats.org/presentationml/2006/main" xmlns:r="http://schemas.openxmlformats.org/officeDocument/2006/relationships">
+  <p:cSld>
+    <p:spTree>
+      <p:nvGrpSpPr>
+        <p:cNvPr id="1" name=""/>
+        <p:cNvGrpSpPr/>
+        <p:nvPr/>
+      </p:nvGrpSpPr>
+      <p:grpSpPr>
+        <a:xfrm>
+          <a:off x="0" y="0"/>
+          <a:ext cx="0" cy="0"/>
+          <a:chOff x="0" y="0"/>
+          <a:chExt cx="0" cy="0"/>
+        </a:xfrm>
+      </p:grpSpPr>
+      <p:sp>
+        <p:nvSpPr>
+          <p:cNvPr id="2" name="Slide Image Placeholder 1"/>
+          <p:cNvSpPr>
+            <a:spLocks noGrp="1"/>
+          </p:cNvSpPr>
+          <p:nvPr>
+            <p:ph type="sldImg" idx="2"/>
+          </p:nvPr>
+        </p:nvSpPr>
+        <p:spPr/>
+      </p:sp>
+      <p:sp>
+        <p:nvSpPr>
+          <p:cNvPr id="3" name="Notes Placeholder 2"/>
+          <p:cNvSpPr>
+            <a:spLocks noGrp="1"/>
+          </p:cNvSpPr>
+          <p:nvPr>
+            <p:ph type="body" idx="3" sz="quarter"/>
+          </p:nvPr>
+        </p:nvSpPr>
+        <p:spPr/>
+        <p:txBody>
+          <a:bodyPr/>
+          <a:lstStyle/>
+          <a:p>
+            <a:r>
+              <a:t>Mentor review summary: 17. Bug Creation and Assignment Activity Flow — Detail 2/2. Use this diagram to explain the actors/components, the direction of the flow, the CAP/backend control boundary, and the observable data or side effect. Canonical source asset: 17-frs-create-assignment.png; editable source and manifest are kept in docs/diagrams/rendered.</a:t>
+            </a:r>
+          </a:p>
+        </p:txBody>
+      </p:sp>
+      <p:sp>
+        <p:nvSpPr>
+          <p:cNvPr id="4" name="Slide Number Placeholder 3"/>
+          <p:cNvSpPr>
+            <a:spLocks noGrp="1"/>
+          </p:cNvSpPr>
+          <p:nvPr>
+            <p:ph type="sldNum" idx="5" sz="quarter"/>
+          </p:nvPr>
+        </p:nvSpPr>
+        <p:spPr/>
+      </p:sp>
+    </p:spTree>
+  </p:cSld>
+  <p:clrMapOvr>
+    <a:masterClrMapping/>
+  </p:clrMapOvr>
+</p:notes>
+</file>
+
+<file path=ppt/notesSlides/notesSlide41.xml><?xml version="1.0" encoding="utf-8"?>
+<p:notes xmlns:a="http://schemas.openxmlformats.org/drawingml/2006/main" xmlns:p="http://schemas.openxmlformats.org/presentationml/2006/main" xmlns:r="http://schemas.openxmlformats.org/officeDocument/2006/relationships">
+  <p:cSld>
+    <p:spTree>
+      <p:nvGrpSpPr>
+        <p:cNvPr id="1" name=""/>
+        <p:cNvGrpSpPr/>
+        <p:nvPr/>
+      </p:nvGrpSpPr>
+      <p:grpSpPr>
+        <a:xfrm>
+          <a:off x="0" y="0"/>
+          <a:ext cx="0" cy="0"/>
+          <a:chOff x="0" y="0"/>
+          <a:chExt cx="0" cy="0"/>
+        </a:xfrm>
+      </p:grpSpPr>
+      <p:sp>
+        <p:nvSpPr>
+          <p:cNvPr id="2" name="Slide Image Placeholder 1"/>
+          <p:cNvSpPr>
+            <a:spLocks noGrp="1"/>
+          </p:cNvSpPr>
+          <p:nvPr>
+            <p:ph type="sldImg" idx="2"/>
+          </p:nvPr>
+        </p:nvSpPr>
+        <p:spPr/>
+      </p:sp>
+      <p:sp>
+        <p:nvSpPr>
+          <p:cNvPr id="3" name="Notes Placeholder 2"/>
+          <p:cNvSpPr>
+            <a:spLocks noGrp="1"/>
+          </p:cNvSpPr>
+          <p:nvPr>
+            <p:ph type="body" idx="3" sz="quarter"/>
+          </p:nvPr>
+        </p:nvSpPr>
+        <p:spPr/>
+        <p:txBody>
+          <a:bodyPr/>
+          <a:lstStyle/>
+          <a:p>
+            <a:r>
+              <a:t>Mentor review summary: 18. Developer Review Decision Flow — Overview. Use this diagram to explain the actors/components, the direction of the flow, the CAP/backend control boundary, and the observable data or side effect. Canonical source asset: 18-frs-developer-review.png; editable source and manifest are kept in docs/diagrams/rendered.</a:t>
+            </a:r>
+          </a:p>
+        </p:txBody>
+      </p:sp>
+      <p:sp>
+        <p:nvSpPr>
+          <p:cNvPr id="4" name="Slide Number Placeholder 3"/>
+          <p:cNvSpPr>
+            <a:spLocks noGrp="1"/>
+          </p:cNvSpPr>
+          <p:nvPr>
+            <p:ph type="sldNum" idx="5" sz="quarter"/>
+          </p:nvPr>
+        </p:nvSpPr>
+        <p:spPr/>
+      </p:sp>
+    </p:spTree>
+  </p:cSld>
+  <p:clrMapOvr>
+    <a:masterClrMapping/>
+  </p:clrMapOvr>
+</p:notes>
+</file>
+
+<file path=ppt/notesSlides/notesSlide42.xml><?xml version="1.0" encoding="utf-8"?>
+<p:notes xmlns:a="http://schemas.openxmlformats.org/drawingml/2006/main" xmlns:p="http://schemas.openxmlformats.org/presentationml/2006/main" xmlns:r="http://schemas.openxmlformats.org/officeDocument/2006/relationships">
+  <p:cSld>
+    <p:spTree>
+      <p:nvGrpSpPr>
+        <p:cNvPr id="1" name=""/>
+        <p:cNvGrpSpPr/>
+        <p:nvPr/>
+      </p:nvGrpSpPr>
+      <p:grpSpPr>
+        <a:xfrm>
+          <a:off x="0" y="0"/>
+          <a:ext cx="0" cy="0"/>
+          <a:chOff x="0" y="0"/>
+          <a:chExt cx="0" cy="0"/>
+        </a:xfrm>
+      </p:grpSpPr>
+      <p:sp>
+        <p:nvSpPr>
+          <p:cNvPr id="2" name="Slide Image Placeholder 1"/>
+          <p:cNvSpPr>
+            <a:spLocks noGrp="1"/>
+          </p:cNvSpPr>
+          <p:nvPr>
+            <p:ph type="sldImg" idx="2"/>
+          </p:nvPr>
+        </p:nvSpPr>
+        <p:spPr/>
+      </p:sp>
+      <p:sp>
+        <p:nvSpPr>
+          <p:cNvPr id="3" name="Notes Placeholder 2"/>
+          <p:cNvSpPr>
+            <a:spLocks noGrp="1"/>
+          </p:cNvSpPr>
+          <p:nvPr>
+            <p:ph type="body" idx="3" sz="quarter"/>
+          </p:nvPr>
+        </p:nvSpPr>
+        <p:spPr/>
+        <p:txBody>
+          <a:bodyPr/>
+          <a:lstStyle/>
+          <a:p>
+            <a:r>
+              <a:t>Mentor review summary: 19. Request More Information Flow — Overview. Use this diagram to explain the actors/components, the direction of the flow, the CAP/backend control boundary, and the observable data or side effect. Canonical source asset: 19-frs-request-more-information.png; editable source and manifest are kept in docs/diagrams/rendered.</a:t>
+            </a:r>
+          </a:p>
+        </p:txBody>
+      </p:sp>
+      <p:sp>
+        <p:nvSpPr>
+          <p:cNvPr id="4" name="Slide Number Placeholder 3"/>
+          <p:cNvSpPr>
+            <a:spLocks noGrp="1"/>
+          </p:cNvSpPr>
+          <p:nvPr>
+            <p:ph type="sldNum" idx="5" sz="quarter"/>
+          </p:nvPr>
+        </p:nvSpPr>
+        <p:spPr/>
+      </p:sp>
+    </p:spTree>
+  </p:cSld>
+  <p:clrMapOvr>
+    <a:masterClrMapping/>
+  </p:clrMapOvr>
+</p:notes>
+</file>
+
+<file path=ppt/notesSlides/notesSlide43.xml><?xml version="1.0" encoding="utf-8"?>
+<p:notes xmlns:a="http://schemas.openxmlformats.org/drawingml/2006/main" xmlns:p="http://schemas.openxmlformats.org/presentationml/2006/main" xmlns:r="http://schemas.openxmlformats.org/officeDocument/2006/relationships">
+  <p:cSld>
+    <p:spTree>
+      <p:nvGrpSpPr>
+        <p:cNvPr id="1" name=""/>
+        <p:cNvGrpSpPr/>
+        <p:nvPr/>
+      </p:nvGrpSpPr>
+      <p:grpSpPr>
+        <a:xfrm>
+          <a:off x="0" y="0"/>
+          <a:ext cx="0" cy="0"/>
+          <a:chOff x="0" y="0"/>
+          <a:chExt cx="0" cy="0"/>
+        </a:xfrm>
+      </p:grpSpPr>
+      <p:sp>
+        <p:nvSpPr>
+          <p:cNvPr id="2" name="Slide Image Placeholder 1"/>
+          <p:cNvSpPr>
+            <a:spLocks noGrp="1"/>
+          </p:cNvSpPr>
+          <p:nvPr>
+            <p:ph type="sldImg" idx="2"/>
+          </p:nvPr>
+        </p:nvSpPr>
+        <p:spPr/>
+      </p:sp>
+      <p:sp>
+        <p:nvSpPr>
+          <p:cNvPr id="3" name="Notes Placeholder 2"/>
+          <p:cNvSpPr>
+            <a:spLocks noGrp="1"/>
+          </p:cNvSpPr>
+          <p:nvPr>
+            <p:ph type="body" idx="3" sz="quarter"/>
+          </p:nvPr>
+        </p:nvSpPr>
+        <p:spPr/>
+        <p:txBody>
+          <a:bodyPr/>
+          <a:lstStyle/>
+          <a:p>
+            <a:r>
+              <a:t>Mentor review summary: 20. Resolve, Retest, Close, and Reopen Flow — Overview. Use this diagram to explain the actors/components, the direction of the flow, the CAP/backend control boundary, and the observable data or side effect. Canonical source asset: 20-frs-resolve-retest-close-reopen.png; editable source and manifest are kept in docs/diagrams/rendered.</a:t>
+            </a:r>
+          </a:p>
+        </p:txBody>
+      </p:sp>
+      <p:sp>
+        <p:nvSpPr>
+          <p:cNvPr id="4" name="Slide Number Placeholder 3"/>
+          <p:cNvSpPr>
+            <a:spLocks noGrp="1"/>
+          </p:cNvSpPr>
+          <p:nvPr>
+            <p:ph type="sldNum" idx="5" sz="quarter"/>
+          </p:nvPr>
+        </p:nvSpPr>
+        <p:spPr/>
+      </p:sp>
+    </p:spTree>
+  </p:cSld>
+  <p:clrMapOvr>
+    <a:masterClrMapping/>
+  </p:clrMapOvr>
+</p:notes>
+</file>
+
+<file path=ppt/notesSlides/notesSlide44.xml><?xml version="1.0" encoding="utf-8"?>
+<p:notes xmlns:a="http://schemas.openxmlformats.org/drawingml/2006/main" xmlns:p="http://schemas.openxmlformats.org/presentationml/2006/main" xmlns:r="http://schemas.openxmlformats.org/officeDocument/2006/relationships">
+  <p:cSld>
+    <p:spTree>
+      <p:nvGrpSpPr>
+        <p:cNvPr id="1" name=""/>
+        <p:cNvGrpSpPr/>
+        <p:nvPr/>
+      </p:nvGrpSpPr>
+      <p:grpSpPr>
+        <a:xfrm>
+          <a:off x="0" y="0"/>
+          <a:ext cx="0" cy="0"/>
+          <a:chOff x="0" y="0"/>
+          <a:chExt cx="0" cy="0"/>
+        </a:xfrm>
+      </p:grpSpPr>
+      <p:sp>
+        <p:nvSpPr>
+          <p:cNvPr id="2" name="Slide Image Placeholder 1"/>
+          <p:cNvSpPr>
+            <a:spLocks noGrp="1"/>
+          </p:cNvSpPr>
+          <p:nvPr>
+            <p:ph type="sldImg" idx="2"/>
+          </p:nvPr>
+        </p:nvSpPr>
+        <p:spPr/>
+      </p:sp>
+      <p:sp>
+        <p:nvSpPr>
+          <p:cNvPr id="3" name="Notes Placeholder 2"/>
+          <p:cNvSpPr>
+            <a:spLocks noGrp="1"/>
+          </p:cNvSpPr>
+          <p:nvPr>
+            <p:ph type="body" idx="3" sz="quarter"/>
+          </p:nvPr>
+        </p:nvSpPr>
+        <p:spPr/>
+        <p:txBody>
+          <a:bodyPr/>
+          <a:lstStyle/>
+          <a:p>
+            <a:r>
+              <a:t>Mentor review summary: 20. Resolve, Retest, Close, and Reopen Flow — Detail 1/2. Use this diagram to explain the actors/components, the direction of the flow, the CAP/backend control boundary, and the observable data or side effect. Canonical source asset: 20-frs-resolve-retest-close-reopen.png; editable source and manifest are kept in docs/diagrams/rendered.</a:t>
+            </a:r>
+          </a:p>
+        </p:txBody>
+      </p:sp>
+      <p:sp>
+        <p:nvSpPr>
+          <p:cNvPr id="4" name="Slide Number Placeholder 3"/>
+          <p:cNvSpPr>
+            <a:spLocks noGrp="1"/>
+          </p:cNvSpPr>
+          <p:nvPr>
+            <p:ph type="sldNum" idx="5" sz="quarter"/>
+          </p:nvPr>
+        </p:nvSpPr>
+        <p:spPr/>
+      </p:sp>
+    </p:spTree>
+  </p:cSld>
+  <p:clrMapOvr>
+    <a:masterClrMapping/>
+  </p:clrMapOvr>
+</p:notes>
+</file>
+
+<file path=ppt/notesSlides/notesSlide45.xml><?xml version="1.0" encoding="utf-8"?>
+<p:notes xmlns:a="http://schemas.openxmlformats.org/drawingml/2006/main" xmlns:p="http://schemas.openxmlformats.org/presentationml/2006/main" xmlns:r="http://schemas.openxmlformats.org/officeDocument/2006/relationships">
+  <p:cSld>
+    <p:spTree>
+      <p:nvGrpSpPr>
+        <p:cNvPr id="1" name=""/>
+        <p:cNvGrpSpPr/>
+        <p:nvPr/>
+      </p:nvGrpSpPr>
+      <p:grpSpPr>
+        <a:xfrm>
+          <a:off x="0" y="0"/>
+          <a:ext cx="0" cy="0"/>
+          <a:chOff x="0" y="0"/>
+          <a:chExt cx="0" cy="0"/>
+        </a:xfrm>
+      </p:grpSpPr>
+      <p:sp>
+        <p:nvSpPr>
+          <p:cNvPr id="2" name="Slide Image Placeholder 1"/>
+          <p:cNvSpPr>
+            <a:spLocks noGrp="1"/>
+          </p:cNvSpPr>
+          <p:nvPr>
+            <p:ph type="sldImg" idx="2"/>
+          </p:nvPr>
+        </p:nvSpPr>
+        <p:spPr/>
+      </p:sp>
+      <p:sp>
+        <p:nvSpPr>
+          <p:cNvPr id="3" name="Notes Placeholder 2"/>
+          <p:cNvSpPr>
+            <a:spLocks noGrp="1"/>
+          </p:cNvSpPr>
+          <p:nvPr>
+            <p:ph type="body" idx="3" sz="quarter"/>
+          </p:nvPr>
+        </p:nvSpPr>
+        <p:spPr/>
+        <p:txBody>
+          <a:bodyPr/>
+          <a:lstStyle/>
+          <a:p>
+            <a:r>
+              <a:t>Mentor review summary: 20. Resolve, Retest, Close, and Reopen Flow — Detail 2/2. Use this diagram to explain the actors/components, the direction of the flow, the CAP/backend control boundary, and the observable data or side effect. Canonical source asset: 20-frs-resolve-retest-close-reopen.png; editable source and manifest are kept in docs/diagrams/rendered.</a:t>
+            </a:r>
+          </a:p>
+        </p:txBody>
+      </p:sp>
+      <p:sp>
+        <p:nvSpPr>
+          <p:cNvPr id="4" name="Slide Number Placeholder 3"/>
+          <p:cNvSpPr>
+            <a:spLocks noGrp="1"/>
+          </p:cNvSpPr>
+          <p:nvPr>
+            <p:ph type="sldNum" idx="5" sz="quarter"/>
+          </p:nvPr>
+        </p:nvSpPr>
+        <p:spPr/>
+      </p:sp>
+    </p:spTree>
+  </p:cSld>
+  <p:clrMapOvr>
+    <a:masterClrMapping/>
+  </p:clrMapOvr>
+</p:notes>
+</file>
+
+<file path=ppt/notesSlides/notesSlide46.xml><?xml version="1.0" encoding="utf-8"?>
+<p:notes xmlns:a="http://schemas.openxmlformats.org/drawingml/2006/main" xmlns:p="http://schemas.openxmlformats.org/presentationml/2006/main" xmlns:r="http://schemas.openxmlformats.org/officeDocument/2006/relationships">
+  <p:cSld>
+    <p:spTree>
+      <p:nvGrpSpPr>
+        <p:cNvPr id="1" name=""/>
+        <p:cNvGrpSpPr/>
+        <p:nvPr/>
+      </p:nvGrpSpPr>
+      <p:grpSpPr>
+        <a:xfrm>
+          <a:off x="0" y="0"/>
+          <a:ext cx="0" cy="0"/>
+          <a:chOff x="0" y="0"/>
+          <a:chExt cx="0" cy="0"/>
+        </a:xfrm>
+      </p:grpSpPr>
+      <p:sp>
+        <p:nvSpPr>
+          <p:cNvPr id="2" name="Slide Image Placeholder 1"/>
+          <p:cNvSpPr>
+            <a:spLocks noGrp="1"/>
+          </p:cNvSpPr>
+          <p:nvPr>
+            <p:ph type="sldImg" idx="2"/>
+          </p:nvPr>
+        </p:nvSpPr>
+        <p:spPr/>
+      </p:sp>
+      <p:sp>
+        <p:nvSpPr>
+          <p:cNvPr id="3" name="Notes Placeholder 2"/>
+          <p:cNvSpPr>
+            <a:spLocks noGrp="1"/>
+          </p:cNvSpPr>
+          <p:nvPr>
+            <p:ph type="body" idx="3" sz="quarter"/>
+          </p:nvPr>
+        </p:nvSpPr>
+        <p:spPr/>
+        <p:txBody>
+          <a:bodyPr/>
+          <a:lstStyle/>
+          <a:p>
+            <a:r>
+              <a:t>Mentor review summary: 21. PM Monitoring and Escalation Flow — Overview. Use this diagram to explain the actors/components, the direction of the flow, the CAP/backend control boundary, and the observable data or side effect. Canonical source asset: 21-frs-pm-monitoring.png; editable source and manifest are kept in docs/diagrams/rendered.</a:t>
+            </a:r>
+          </a:p>
+        </p:txBody>
+      </p:sp>
+      <p:sp>
+        <p:nvSpPr>
+          <p:cNvPr id="4" name="Slide Number Placeholder 3"/>
+          <p:cNvSpPr>
+            <a:spLocks noGrp="1"/>
+          </p:cNvSpPr>
+          <p:nvPr>
+            <p:ph type="sldNum" idx="5" sz="quarter"/>
+          </p:nvPr>
+        </p:nvSpPr>
+        <p:spPr/>
+      </p:sp>
+    </p:spTree>
+  </p:cSld>
+  <p:clrMapOvr>
+    <a:masterClrMapping/>
+  </p:clrMapOvr>
+</p:notes>
+</file>
+
+<file path=ppt/notesSlides/notesSlide5.xml><?xml version="1.0" encoding="utf-8"?>
+<p:notes xmlns:a="http://schemas.openxmlformats.org/drawingml/2006/main" xmlns:p="http://schemas.openxmlformats.org/presentationml/2006/main" xmlns:r="http://schemas.openxmlformats.org/officeDocument/2006/relationships">
+  <p:cSld>
+    <p:spTree>
+      <p:nvGrpSpPr>
+        <p:cNvPr id="1" name=""/>
+        <p:cNvGrpSpPr/>
+        <p:nvPr/>
+      </p:nvGrpSpPr>
+      <p:grpSpPr>
+        <a:xfrm>
+          <a:off x="0" y="0"/>
+          <a:ext cx="0" cy="0"/>
+          <a:chOff x="0" y="0"/>
+          <a:chExt cx="0" cy="0"/>
+        </a:xfrm>
+      </p:grpSpPr>
+      <p:sp>
+        <p:nvSpPr>
+          <p:cNvPr id="2" name="Slide Image Placeholder 1"/>
+          <p:cNvSpPr>
+            <a:spLocks noGrp="1"/>
+          </p:cNvSpPr>
+          <p:nvPr>
+            <p:ph type="sldImg" idx="2"/>
+          </p:nvPr>
+        </p:nvSpPr>
+        <p:spPr/>
+      </p:sp>
+      <p:sp>
+        <p:nvSpPr>
+          <p:cNvPr id="3" name="Notes Placeholder 2"/>
+          <p:cNvSpPr>
+            <a:spLocks noGrp="1"/>
+          </p:cNvSpPr>
+          <p:nvPr>
+            <p:ph type="body" idx="3" sz="quarter"/>
+          </p:nvPr>
+        </p:nvSpPr>
+        <p:spPr/>
+        <p:txBody>
+          <a:bodyPr/>
+          <a:lstStyle/>
+          <a:p>
+            <a:r>
+              <a:t>Mentor review summary: 03. Use Case Diagram — Detail 2/3. Use this diagram to explain the actors/components, the direction of the flow, the CAP/backend control boundary, and the observable data or side effect. Canonical source asset: 03-use-case.png; editable source and manifest are kept in docs/diagrams/rendered.</a:t>
+            </a:r>
+          </a:p>
+        </p:txBody>
+      </p:sp>
+      <p:sp>
+        <p:nvSpPr>
+          <p:cNvPr id="4" name="Slide Number Placeholder 3"/>
+          <p:cNvSpPr>
+            <a:spLocks noGrp="1"/>
+          </p:cNvSpPr>
+          <p:nvPr>
+            <p:ph type="sldNum" idx="5" sz="quarter"/>
+          </p:nvPr>
+        </p:nvSpPr>
+        <p:spPr/>
+      </p:sp>
+    </p:spTree>
+  </p:cSld>
+  <p:clrMapOvr>
+    <a:masterClrMapping/>
+  </p:clrMapOvr>
+</p:notes>
+</file>
+
+<file path=ppt/notesSlides/notesSlide6.xml><?xml version="1.0" encoding="utf-8"?>
+<p:notes xmlns:a="http://schemas.openxmlformats.org/drawingml/2006/main" xmlns:p="http://schemas.openxmlformats.org/presentationml/2006/main" xmlns:r="http://schemas.openxmlformats.org/officeDocument/2006/relationships">
+  <p:cSld>
+    <p:spTree>
+      <p:nvGrpSpPr>
+        <p:cNvPr id="1" name=""/>
+        <p:cNvGrpSpPr/>
+        <p:nvPr/>
+      </p:nvGrpSpPr>
+      <p:grpSpPr>
+        <a:xfrm>
+          <a:off x="0" y="0"/>
+          <a:ext cx="0" cy="0"/>
+          <a:chOff x="0" y="0"/>
+          <a:chExt cx="0" cy="0"/>
+        </a:xfrm>
+      </p:grpSpPr>
+      <p:sp>
+        <p:nvSpPr>
+          <p:cNvPr id="2" name="Slide Image Placeholder 1"/>
+          <p:cNvSpPr>
+            <a:spLocks noGrp="1"/>
+          </p:cNvSpPr>
+          <p:nvPr>
+            <p:ph type="sldImg" idx="2"/>
+          </p:nvPr>
+        </p:nvSpPr>
+        <p:spPr/>
+      </p:sp>
+      <p:sp>
+        <p:nvSpPr>
+          <p:cNvPr id="3" name="Notes Placeholder 2"/>
+          <p:cNvSpPr>
+            <a:spLocks noGrp="1"/>
+          </p:cNvSpPr>
+          <p:nvPr>
+            <p:ph type="body" idx="3" sz="quarter"/>
+          </p:nvPr>
+        </p:nvSpPr>
+        <p:spPr/>
+        <p:txBody>
+          <a:bodyPr/>
+          <a:lstStyle/>
+          <a:p>
+            <a:r>
+              <a:t>Mentor review summary: 03. Use Case Diagram — Detail 3/3. Use this diagram to explain the actors/components, the direction of the flow, the CAP/backend control boundary, and the observable data or side effect. Canonical source asset: 03-use-case.png; editable source and manifest are kept in docs/diagrams/rendered.</a:t>
+            </a:r>
+          </a:p>
+        </p:txBody>
+      </p:sp>
+      <p:sp>
+        <p:nvSpPr>
+          <p:cNvPr id="4" name="Slide Number Placeholder 3"/>
+          <p:cNvSpPr>
+            <a:spLocks noGrp="1"/>
+          </p:cNvSpPr>
+          <p:nvPr>
+            <p:ph type="sldNum" idx="5" sz="quarter"/>
+          </p:nvPr>
+        </p:nvSpPr>
+        <p:spPr/>
+      </p:sp>
+    </p:spTree>
+  </p:cSld>
+  <p:clrMapOvr>
+    <a:masterClrMapping/>
+  </p:clrMapOvr>
+</p:notes>
+</file>
+
+<file path=ppt/notesSlides/notesSlide7.xml><?xml version="1.0" encoding="utf-8"?>
+<p:notes xmlns:a="http://schemas.openxmlformats.org/drawingml/2006/main" xmlns:p="http://schemas.openxmlformats.org/presentationml/2006/main" xmlns:r="http://schemas.openxmlformats.org/officeDocument/2006/relationships">
+  <p:cSld>
+    <p:spTree>
+      <p:nvGrpSpPr>
+        <p:cNvPr id="1" name=""/>
+        <p:cNvGrpSpPr/>
+        <p:nvPr/>
+      </p:nvGrpSpPr>
+      <p:grpSpPr>
+        <a:xfrm>
+          <a:off x="0" y="0"/>
+          <a:ext cx="0" cy="0"/>
+          <a:chOff x="0" y="0"/>
+          <a:chExt cx="0" cy="0"/>
+        </a:xfrm>
+      </p:grpSpPr>
+      <p:sp>
+        <p:nvSpPr>
+          <p:cNvPr id="2" name="Slide Image Placeholder 1"/>
+          <p:cNvSpPr>
+            <a:spLocks noGrp="1"/>
+          </p:cNvSpPr>
+          <p:nvPr>
+            <p:ph type="sldImg" idx="2"/>
+          </p:nvPr>
+        </p:nvSpPr>
+        <p:spPr/>
+      </p:sp>
+      <p:sp>
+        <p:nvSpPr>
+          <p:cNvPr id="3" name="Notes Placeholder 2"/>
+          <p:cNvSpPr>
+            <a:spLocks noGrp="1"/>
+          </p:cNvSpPr>
+          <p:nvPr>
+            <p:ph type="body" idx="3" sz="quarter"/>
+          </p:nvPr>
+        </p:nvSpPr>
+        <p:spPr/>
+        <p:txBody>
+          <a:bodyPr/>
+          <a:lstStyle/>
+          <a:p>
+            <a:r>
+              <a:t>Mentor review summary: 04. End-to-End Defect Tracking Flow — Overview. Use this diagram to explain the actors/components, the direction of the flow, the CAP/backend control boundary, and the observable data or side effect. Canonical source asset: 04-end-to-end-defect-flow.png; editable source and manifest are kept in docs/diagrams/rendered.</a:t>
+            </a:r>
+          </a:p>
+        </p:txBody>
+      </p:sp>
+      <p:sp>
+        <p:nvSpPr>
+          <p:cNvPr id="4" name="Slide Number Placeholder 3"/>
+          <p:cNvSpPr>
+            <a:spLocks noGrp="1"/>
+          </p:cNvSpPr>
+          <p:nvPr>
+            <p:ph type="sldNum" idx="5" sz="quarter"/>
+          </p:nvPr>
+        </p:nvSpPr>
+        <p:spPr/>
+      </p:sp>
+    </p:spTree>
+  </p:cSld>
+  <p:clrMapOvr>
+    <a:masterClrMapping/>
+  </p:clrMapOvr>
+</p:notes>
+</file>
+
+<file path=ppt/notesSlides/notesSlide8.xml><?xml version="1.0" encoding="utf-8"?>
+<p:notes xmlns:a="http://schemas.openxmlformats.org/drawingml/2006/main" xmlns:p="http://schemas.openxmlformats.org/presentationml/2006/main" xmlns:r="http://schemas.openxmlformats.org/officeDocument/2006/relationships">
+  <p:cSld>
+    <p:spTree>
+      <p:nvGrpSpPr>
+        <p:cNvPr id="1" name=""/>
+        <p:cNvGrpSpPr/>
+        <p:nvPr/>
+      </p:nvGrpSpPr>
+      <p:grpSpPr>
+        <a:xfrm>
+          <a:off x="0" y="0"/>
+          <a:ext cx="0" cy="0"/>
+          <a:chOff x="0" y="0"/>
+          <a:chExt cx="0" cy="0"/>
+        </a:xfrm>
+      </p:grpSpPr>
+      <p:sp>
+        <p:nvSpPr>
+          <p:cNvPr id="2" name="Slide Image Placeholder 1"/>
+          <p:cNvSpPr>
+            <a:spLocks noGrp="1"/>
+          </p:cNvSpPr>
+          <p:nvPr>
+            <p:ph type="sldImg" idx="2"/>
+          </p:nvPr>
+        </p:nvSpPr>
+        <p:spPr/>
+      </p:sp>
+      <p:sp>
+        <p:nvSpPr>
+          <p:cNvPr id="3" name="Notes Placeholder 2"/>
+          <p:cNvSpPr>
+            <a:spLocks noGrp="1"/>
+          </p:cNvSpPr>
+          <p:nvPr>
+            <p:ph type="body" idx="3" sz="quarter"/>
+          </p:nvPr>
+        </p:nvSpPr>
+        <p:spPr/>
+        <p:txBody>
+          <a:bodyPr/>
+          <a:lstStyle/>
+          <a:p>
+            <a:r>
+              <a:t>Mentor review summary: 04. End-to-End Defect Tracking Flow — Detail 1/3. Use this diagram to explain the actors/components, the direction of the flow, the CAP/backend control boundary, and the observable data or side effect. Canonical source asset: 04-end-to-end-defect-flow.png; editable source and manifest are kept in docs/diagrams/rendered.</a:t>
+            </a:r>
+          </a:p>
+        </p:txBody>
+      </p:sp>
+      <p:sp>
+        <p:nvSpPr>
+          <p:cNvPr id="4" name="Slide Number Placeholder 3"/>
+          <p:cNvSpPr>
+            <a:spLocks noGrp="1"/>
+          </p:cNvSpPr>
+          <p:nvPr>
+            <p:ph type="sldNum" idx="5" sz="quarter"/>
+          </p:nvPr>
+        </p:nvSpPr>
+        <p:spPr/>
+      </p:sp>
+    </p:spTree>
+  </p:cSld>
+  <p:clrMapOvr>
+    <a:masterClrMapping/>
+  </p:clrMapOvr>
+</p:notes>
+</file>
+
+<file path=ppt/notesSlides/notesSlide9.xml><?xml version="1.0" encoding="utf-8"?>
+<p:notes xmlns:a="http://schemas.openxmlformats.org/drawingml/2006/main" xmlns:p="http://schemas.openxmlformats.org/presentationml/2006/main" xmlns:r="http://schemas.openxmlformats.org/officeDocument/2006/relationships">
+  <p:cSld>
+    <p:spTree>
+      <p:nvGrpSpPr>
+        <p:cNvPr id="1" name=""/>
+        <p:cNvGrpSpPr/>
+        <p:nvPr/>
+      </p:nvGrpSpPr>
+      <p:grpSpPr>
+        <a:xfrm>
+          <a:off x="0" y="0"/>
+          <a:ext cx="0" cy="0"/>
+          <a:chOff x="0" y="0"/>
+          <a:chExt cx="0" cy="0"/>
+        </a:xfrm>
+      </p:grpSpPr>
+      <p:sp>
+        <p:nvSpPr>
+          <p:cNvPr id="2" name="Slide Image Placeholder 1"/>
+          <p:cNvSpPr>
+            <a:spLocks noGrp="1"/>
+          </p:cNvSpPr>
+          <p:nvPr>
+            <p:ph type="sldImg" idx="2"/>
+          </p:nvPr>
+        </p:nvSpPr>
+        <p:spPr/>
+      </p:sp>
+      <p:sp>
+        <p:nvSpPr>
+          <p:cNvPr id="3" name="Notes Placeholder 2"/>
+          <p:cNvSpPr>
+            <a:spLocks noGrp="1"/>
+          </p:cNvSpPr>
+          <p:nvPr>
+            <p:ph type="body" idx="3" sz="quarter"/>
+          </p:nvPr>
+        </p:nvSpPr>
+        <p:spPr/>
+        <p:txBody>
+          <a:bodyPr/>
+          <a:lstStyle/>
+          <a:p>
+            <a:r>
+              <a:t>Mentor review summary: 04. End-to-End Defect Tracking Flow — Detail 2/3. Use this diagram to explain the actors/components, the direction of the flow, the CAP/backend control boundary, and the observable data or side effect. Canonical source asset: 04-end-to-end-defect-flow.png; editable source and manifest are kept in docs/diagrams/rendered.</a:t>
+            </a:r>
+          </a:p>
+        </p:txBody>
+      </p:sp>
+      <p:sp>
+        <p:nvSpPr>
+          <p:cNvPr id="4" name="Slide Number Placeholder 3"/>
+          <p:cNvSpPr>
+            <a:spLocks noGrp="1"/>
+          </p:cNvSpPr>
+          <p:nvPr>
+            <p:ph type="sldNum" idx="5" sz="quarter"/>
+          </p:nvPr>
+        </p:nvSpPr>
+        <p:spPr/>
+      </p:sp>
+    </p:spTree>
+  </p:cSld>
+  <p:clrMapOvr>
+    <a:masterClrMapping/>
+  </p:clrMapOvr>
+</p:notes>
 </file>
 
 <file path=ppt/slideLayouts/slideLayout1.xml><?xml version="1.0" encoding="utf-8"?>
@@ -4131,7 +7701,7 @@
                 </a:solidFill>
                 <a:latin typeface="Aptos Display"/>
               </a:rPr>
-              <a:t>08. 04 - Bug Status Lifecycle — Overview</a:t>
+              <a:t>08. Bug Status Lifecycle — Overview</a:t>
             </a:r>
           </a:p>
         </p:txBody>
@@ -4251,7 +7821,7 @@
                 </a:solidFill>
                 <a:latin typeface="Aptos Display"/>
               </a:rPr>
-              <a:t>08. 04 - Bug Status Lifecycle — Detail 1/2</a:t>
+              <a:t>08. Bug Status Lifecycle — Detail 1/2</a:t>
             </a:r>
           </a:p>
         </p:txBody>
@@ -4371,7 +7941,7 @@
                 </a:solidFill>
                 <a:latin typeface="Aptos Display"/>
               </a:rPr>
-              <a:t>08. 04 - Bug Status Lifecycle — Detail 2/2</a:t>
+              <a:t>08. Bug Status Lifecycle — Detail 2/2</a:t>
             </a:r>
           </a:p>
         </p:txBody>
@@ -4611,7 +8181,7 @@
                 </a:solidFill>
                 <a:latin typeface="Aptos Display"/>
               </a:rPr>
-              <a:t>09. 05 - Conceptual Data Model — Overview</a:t>
+              <a:t>09. Conceptual Data Model — Overview</a:t>
             </a:r>
           </a:p>
         </p:txBody>
@@ -4731,7 +8301,7 @@
                 </a:solidFill>
                 <a:latin typeface="Aptos Display"/>
               </a:rPr>
-              <a:t>09. 05 - Conceptual Data Model — Detail 1/4</a:t>
+              <a:t>09. Conceptual Data Model — Detail 1/4</a:t>
             </a:r>
           </a:p>
         </p:txBody>
@@ -4851,7 +8421,7 @@
                 </a:solidFill>
                 <a:latin typeface="Aptos Display"/>
               </a:rPr>
-              <a:t>09. 05 - Conceptual Data Model — Detail 2/4</a:t>
+              <a:t>09. Conceptual Data Model — Detail 2/4</a:t>
             </a:r>
           </a:p>
         </p:txBody>
@@ -4971,7 +8541,7 @@
                 </a:solidFill>
                 <a:latin typeface="Aptos Display"/>
               </a:rPr>
-              <a:t>09. 05 - Conceptual Data Model — Detail 3/4</a:t>
+              <a:t>09. Conceptual Data Model — Detail 3/4</a:t>
             </a:r>
           </a:p>
         </p:txBody>
@@ -5091,7 +8661,7 @@
                 </a:solidFill>
                 <a:latin typeface="Aptos Display"/>
               </a:rPr>
-              <a:t>09. 05 - Conceptual Data Model — Detail 4/4</a:t>
+              <a:t>09. Conceptual Data Model — Detail 4/4</a:t>
             </a:r>
           </a:p>
         </p:txBody>
@@ -5811,7 +9381,7 @@
                 </a:solidFill>
                 <a:latin typeface="Aptos Display"/>
               </a:rPr>
-              <a:t>03. 02 - Use Case Diagram — Overview</a:t>
+              <a:t>03. Use Case Diagram — Overview</a:t>
             </a:r>
           </a:p>
         </p:txBody>
@@ -6171,7 +9741,7 @@
                 </a:solidFill>
                 <a:latin typeface="Aptos Display"/>
               </a:rPr>
-              <a:t>13. 07 - SRS System Context — Overview</a:t>
+              <a:t>13. SRS System Context — Overview</a:t>
             </a:r>
           </a:p>
         </p:txBody>
@@ -7131,7 +10701,7 @@
                 </a:solidFill>
                 <a:latin typeface="Aptos Display"/>
               </a:rPr>
-              <a:t>03. 02 - Use Case Diagram — Detail 1/3</a:t>
+              <a:t>03. Use Case Diagram — Detail 1/3</a:t>
             </a:r>
           </a:p>
         </p:txBody>
@@ -8091,7 +11661,7 @@
                 </a:solidFill>
                 <a:latin typeface="Aptos Display"/>
               </a:rPr>
-              <a:t>03. 02 - Use Case Diagram — Detail 2/3</a:t>
+              <a:t>03. Use Case Diagram — Detail 2/3</a:t>
             </a:r>
           </a:p>
         </p:txBody>
@@ -8211,7 +11781,7 @@
                 </a:solidFill>
                 <a:latin typeface="Aptos Display"/>
               </a:rPr>
-              <a:t>03. 02 - Use Case Diagram — Detail 3/3</a:t>
+              <a:t>03. Use Case Diagram — Detail 3/3</a:t>
             </a:r>
           </a:p>
         </p:txBody>
@@ -8961,4 +12531,324 @@
   </a:objectDefaults>
   <a:extraClrSchemeLst/>
 </a:theme>
+</file>
+
+<file path=ppt/theme/theme2.xml><?xml version="1.0" encoding="utf-8"?>
+<a:theme xmlns:a="http://schemas.openxmlformats.org/drawingml/2006/main" name="Office Theme">
+  <a:themeElements>
+    <a:clrScheme name="Office">
+      <a:dk1>
+        <a:sysClr val="windowText" lastClr="000000"/>
+      </a:dk1>
+      <a:lt1>
+        <a:sysClr val="window" lastClr="FFFFFF"/>
+      </a:lt1>
+      <a:dk2>
+        <a:srgbClr val="1F497D"/>
+      </a:dk2>
+      <a:lt2>
+        <a:srgbClr val="EEECE1"/>
+      </a:lt2>
+      <a:accent1>
+        <a:srgbClr val="4F81BD"/>
+      </a:accent1>
+      <a:accent2>
+        <a:srgbClr val="C0504D"/>
+      </a:accent2>
+      <a:accent3>
+        <a:srgbClr val="9BBB59"/>
+      </a:accent3>
+      <a:accent4>
+        <a:srgbClr val="8064A2"/>
+      </a:accent4>
+      <a:accent5>
+        <a:srgbClr val="4BACC6"/>
+      </a:accent5>
+      <a:accent6>
+        <a:srgbClr val="F79646"/>
+      </a:accent6>
+      <a:hlink>
+        <a:srgbClr val="0000FF"/>
+      </a:hlink>
+      <a:folHlink>
+        <a:srgbClr val="800080"/>
+      </a:folHlink>
+    </a:clrScheme>
+    <a:fontScheme name="Office">
+      <a:majorFont>
+        <a:latin typeface="Calibri"/>
+        <a:ea typeface=""/>
+        <a:cs typeface=""/>
+        <a:font script="Jpan" typeface="ＭＳ Ｐゴシック"/>
+        <a:font script="Hang" typeface="맑은 고딕"/>
+        <a:font script="Hans" typeface="宋体"/>
+        <a:font script="Hant" typeface="新細明體"/>
+        <a:font script="Arab" typeface="Times New Roman"/>
+        <a:font script="Hebr" typeface="Times New Roman"/>
+        <a:font script="Thai" typeface="Angsana New"/>
+        <a:font script="Ethi" typeface="Nyala"/>
+        <a:font script="Beng" typeface="Vrinda"/>
+        <a:font script="Gujr" typeface="Shruti"/>
+        <a:font script="Khmr" typeface="MoolBoran"/>
+        <a:font script="Knda" typeface="Tunga"/>
+        <a:font script="Guru" typeface="Raavi"/>
+        <a:font script="Cans" typeface="Euphemia"/>
+        <a:font script="Cher" typeface="Plantagenet Cherokee"/>
+        <a:font script="Yiii" typeface="Microsoft Yi Baiti"/>
+        <a:font script="Tibt" typeface="Microsoft Himalaya"/>
+        <a:font script="Thaa" typeface="MV Boli"/>
+        <a:font script="Deva" typeface="Mangal"/>
+        <a:font script="Telu" typeface="Gautami"/>
+        <a:font script="Taml" typeface="Latha"/>
+        <a:font script="Syrc" typeface="Estrangelo Edessa"/>
+        <a:font script="Orya" typeface="Kalinga"/>
+        <a:font script="Mlym" typeface="Kartika"/>
+        <a:font script="Laoo" typeface="DokChampa"/>
+        <a:font script="Sinh" typeface="Iskoola Pota"/>
+        <a:font script="Mong" typeface="Mongolian Baiti"/>
+        <a:font script="Viet" typeface="Times New Roman"/>
+        <a:font script="Uigh" typeface="Microsoft Uighur"/>
+        <a:font script="Geor" typeface="Sylfaen"/>
+      </a:majorFont>
+      <a:minorFont>
+        <a:latin typeface="Calibri"/>
+        <a:ea typeface=""/>
+        <a:cs typeface=""/>
+        <a:font script="Jpan" typeface="ＭＳ Ｐゴシック"/>
+        <a:font script="Hang" typeface="맑은 고딕"/>
+        <a:font script="Hans" typeface="宋体"/>
+        <a:font script="Hant" typeface="新細明體"/>
+        <a:font script="Arab" typeface="Arial"/>
+        <a:font script="Hebr" typeface="Arial"/>
+        <a:font script="Thai" typeface="Cordia New"/>
+        <a:font script="Ethi" typeface="Nyala"/>
+        <a:font script="Beng" typeface="Vrinda"/>
+        <a:font script="Gujr" typeface="Shruti"/>
+        <a:font script="Khmr" typeface="DaunPenh"/>
+        <a:font script="Knda" typeface="Tunga"/>
+        <a:font script="Guru" typeface="Raavi"/>
+        <a:font script="Cans" typeface="Euphemia"/>
+        <a:font script="Cher" typeface="Plantagenet Cherokee"/>
+        <a:font script="Yiii" typeface="Microsoft Yi Baiti"/>
+        <a:font script="Tibt" typeface="Microsoft Himalaya"/>
+        <a:font script="Thaa" typeface="MV Boli"/>
+        <a:font script="Deva" typeface="Mangal"/>
+        <a:font script="Telu" typeface="Gautami"/>
+        <a:font script="Taml" typeface="Latha"/>
+        <a:font script="Syrc" typeface="Estrangelo Edessa"/>
+        <a:font script="Orya" typeface="Kalinga"/>
+        <a:font script="Mlym" typeface="Kartika"/>
+        <a:font script="Laoo" typeface="DokChampa"/>
+        <a:font script="Sinh" typeface="Iskoola Pota"/>
+        <a:font script="Mong" typeface="Mongolian Baiti"/>
+        <a:font script="Viet" typeface="Arial"/>
+        <a:font script="Uigh" typeface="Microsoft Uighur"/>
+        <a:font script="Geor" typeface="Sylfaen"/>
+      </a:minorFont>
+    </a:fontScheme>
+    <a:fmtScheme name="Office">
+      <a:fillStyleLst>
+        <a:solidFill>
+          <a:schemeClr val="phClr"/>
+        </a:solidFill>
+        <a:gradFill rotWithShape="1">
+          <a:gsLst>
+            <a:gs pos="0">
+              <a:schemeClr val="phClr">
+                <a:tint val="50000"/>
+                <a:satMod val="300000"/>
+              </a:schemeClr>
+            </a:gs>
+            <a:gs pos="35000">
+              <a:schemeClr val="phClr">
+                <a:tint val="37000"/>
+                <a:satMod val="300000"/>
+              </a:schemeClr>
+            </a:gs>
+            <a:gs pos="100000">
+              <a:schemeClr val="phClr">
+                <a:tint val="15000"/>
+                <a:satMod val="350000"/>
+              </a:schemeClr>
+            </a:gs>
+          </a:gsLst>
+          <a:lin ang="16200000" scaled="1"/>
+        </a:gradFill>
+        <a:gradFill rotWithShape="1">
+          <a:gsLst>
+            <a:gs pos="0">
+              <a:schemeClr val="phClr">
+                <a:tint val="100000"/>
+                <a:shade val="100000"/>
+                <a:satMod val="130000"/>
+              </a:schemeClr>
+            </a:gs>
+            <a:gs pos="100000">
+              <a:schemeClr val="phClr">
+                <a:tint val="50000"/>
+                <a:shade val="100000"/>
+                <a:satMod val="350000"/>
+              </a:schemeClr>
+            </a:gs>
+          </a:gsLst>
+          <a:lin ang="16200000" scaled="0"/>
+        </a:gradFill>
+      </a:fillStyleLst>
+      <a:lnStyleLst>
+        <a:ln w="9525" cap="flat" cmpd="sng" algn="ctr">
+          <a:solidFill>
+            <a:schemeClr val="phClr">
+              <a:shade val="95000"/>
+              <a:satMod val="105000"/>
+            </a:schemeClr>
+          </a:solidFill>
+          <a:prstDash val="solid"/>
+        </a:ln>
+        <a:ln w="25400" cap="flat" cmpd="sng" algn="ctr">
+          <a:solidFill>
+            <a:schemeClr val="phClr"/>
+          </a:solidFill>
+          <a:prstDash val="solid"/>
+        </a:ln>
+        <a:ln w="38100" cap="flat" cmpd="sng" algn="ctr">
+          <a:solidFill>
+            <a:schemeClr val="phClr"/>
+          </a:solidFill>
+          <a:prstDash val="solid"/>
+        </a:ln>
+      </a:lnStyleLst>
+      <a:effectStyleLst>
+        <a:effectStyle>
+          <a:effectLst>
+            <a:outerShdw blurRad="40000" dist="20000" dir="5400000" rotWithShape="0">
+              <a:srgbClr val="000000">
+                <a:alpha val="38000"/>
+              </a:srgbClr>
+            </a:outerShdw>
+          </a:effectLst>
+        </a:effectStyle>
+        <a:effectStyle>
+          <a:effectLst>
+            <a:outerShdw blurRad="40000" dist="23000" dir="5400000" rotWithShape="0">
+              <a:srgbClr val="000000">
+                <a:alpha val="35000"/>
+              </a:srgbClr>
+            </a:outerShdw>
+          </a:effectLst>
+        </a:effectStyle>
+        <a:effectStyle>
+          <a:effectLst>
+            <a:outerShdw blurRad="40000" dist="23000" dir="5400000" rotWithShape="0">
+              <a:srgbClr val="000000">
+                <a:alpha val="35000"/>
+              </a:srgbClr>
+            </a:outerShdw>
+          </a:effectLst>
+          <a:scene3d>
+            <a:camera prst="orthographicFront">
+              <a:rot lat="0" lon="0" rev="0"/>
+            </a:camera>
+            <a:lightRig rig="threePt" dir="t">
+              <a:rot lat="0" lon="0" rev="1200000"/>
+            </a:lightRig>
+          </a:scene3d>
+          <a:sp3d>
+            <a:bevelT w="63500" h="25400"/>
+          </a:sp3d>
+        </a:effectStyle>
+      </a:effectStyleLst>
+      <a:bgFillStyleLst>
+        <a:solidFill>
+          <a:schemeClr val="phClr"/>
+        </a:solidFill>
+        <a:gradFill rotWithShape="1">
+          <a:gsLst>
+            <a:gs pos="0">
+              <a:schemeClr val="phClr">
+                <a:tint val="40000"/>
+                <a:satMod val="350000"/>
+              </a:schemeClr>
+            </a:gs>
+            <a:gs pos="40000">
+              <a:schemeClr val="phClr">
+                <a:tint val="45000"/>
+                <a:shade val="99000"/>
+                <a:satMod val="350000"/>
+              </a:schemeClr>
+            </a:gs>
+            <a:gs pos="100000">
+              <a:schemeClr val="phClr">
+                <a:shade val="20000"/>
+                <a:satMod val="255000"/>
+              </a:schemeClr>
+            </a:gs>
+          </a:gsLst>
+          <a:path path="circle">
+            <a:fillToRect l="50000" t="-80000" r="50000" b="180000"/>
+          </a:path>
+        </a:gradFill>
+        <a:gradFill rotWithShape="1">
+          <a:gsLst>
+            <a:gs pos="0">
+              <a:schemeClr val="phClr">
+                <a:tint val="80000"/>
+                <a:satMod val="300000"/>
+              </a:schemeClr>
+            </a:gs>
+            <a:gs pos="100000">
+              <a:schemeClr val="phClr">
+                <a:shade val="30000"/>
+                <a:satMod val="200000"/>
+              </a:schemeClr>
+            </a:gs>
+          </a:gsLst>
+          <a:path path="circle">
+            <a:fillToRect l="50000" t="50000" r="50000" b="50000"/>
+          </a:path>
+        </a:gradFill>
+      </a:bgFillStyleLst>
+    </a:fmtScheme>
+  </a:themeElements>
+  <a:objectDefaults>
+    <a:spDef>
+      <a:spPr/>
+      <a:bodyPr/>
+      <a:lstStyle/>
+      <a:style>
+        <a:lnRef idx="1">
+          <a:schemeClr val="accent1"/>
+        </a:lnRef>
+        <a:fillRef idx="3">
+          <a:schemeClr val="accent1"/>
+        </a:fillRef>
+        <a:effectRef idx="2">
+          <a:schemeClr val="accent1"/>
+        </a:effectRef>
+        <a:fontRef idx="minor">
+          <a:schemeClr val="lt1"/>
+        </a:fontRef>
+      </a:style>
+    </a:spDef>
+    <a:lnDef>
+      <a:spPr/>
+      <a:bodyPr/>
+      <a:lstStyle/>
+      <a:style>
+        <a:lnRef idx="2">
+          <a:schemeClr val="accent1"/>
+        </a:lnRef>
+        <a:fillRef idx="0">
+          <a:schemeClr val="accent1"/>
+        </a:fillRef>
+        <a:effectRef idx="1">
+          <a:schemeClr val="accent1"/>
+        </a:effectRef>
+        <a:fontRef idx="minor">
+          <a:schemeClr val="tx1"/>
+        </a:fontRef>
+      </a:style>
+    </a:lnDef>
+  </a:objectDefaults>
+  <a:extraClrSchemeLst/>
+</a:theme>
 </file>
</xml_diff>